<commit_message>
Pitch: actualizado con BioScore, Sleep Score, Plan de hoy (IA), respiracion guiada, mapa energia, forecast riesgo y diseno iOS 26
- 2 nuevas slides 'Tu Laboratorio' (mapa energia + forecast 3 dias + respiracion) y 'Bienestar + Coach' (BioScore/Sleep/Plan de hoy/diseno)
- Slide El Producto: +BioScore, Sleep Score, Coach Plan de hoy, respiracion, vidrio iOS26
- Slide Traccion: +10 datasets wearables (30 dias) integrados
- Mismo estilo visual (teal/amber/rose/purple sobre fondo oscuro)
</commit_message>
<xml_diff>
--- a/pitch/BioPulse_Pitch_Final.pptx
+++ b/pitch/BioPulse_Pitch_Final.pptx
@@ -12,6 +12,8 @@
     <p:sldId id="260" r:id="rId6"/>
     <p:sldId id="261" r:id="rId7"/>
     <p:sldId id="262" r:id="rId8"/>
+    <p:sldId id="267" r:id="rId18"/>
+    <p:sldId id="268" r:id="rId19"/>
     <p:sldId id="263" r:id="rId9"/>
     <p:sldId id="264" r:id="rId10"/>
     <p:sldId id="265" r:id="rId11"/>
@@ -2105,6 +2107,1308 @@
 
 <file path=ppt/slides/slide10.xml><?xml version="1.0" encoding="utf-8"?>
 <p:sld xmlns:a="http://schemas.openxmlformats.org/drawingml/2006/main" xmlns:r="http://schemas.openxmlformats.org/officeDocument/2006/relationships" xmlns:p="http://schemas.openxmlformats.org/presentationml/2006/main">
+  <p:cSld name="Slide 8">
+    <p:bg>
+      <p:bgPr>
+        <a:solidFill>
+          <a:srgbClr val="0A1420"/>
+        </a:solidFill>
+      </p:bgPr>
+    </p:bg>
+    <p:spTree>
+      <p:nvGrpSpPr>
+        <p:cNvPr id="1" name=""/>
+        <p:cNvGrpSpPr/>
+        <p:nvPr/>
+      </p:nvGrpSpPr>
+      <p:grpSpPr>
+        <a:xfrm>
+          <a:off x="0" y="0"/>
+          <a:ext cx="0" cy="0"/>
+          <a:chOff x="0" y="0"/>
+          <a:chExt cx="0" cy="0"/>
+        </a:xfrm>
+      </p:grpSpPr>
+      <p:sp>
+        <p:nvSpPr>
+          <p:cNvPr id="2" name="Text 0"/>
+          <p:cNvSpPr/>
+          <p:nvPr/>
+        </p:nvSpPr>
+        <p:spPr>
+          <a:xfrm>
+            <a:off x="640080" y="457200"/>
+            <a:ext cx="10881360" cy="274320"/>
+          </a:xfrm>
+          <a:prstGeom prst="rect">
+            <a:avLst/>
+          </a:prstGeom>
+          <a:noFill/>
+          <a:ln/>
+        </p:spPr>
+        <p:txBody>
+          <a:bodyPr wrap="square" lIns="0" tIns="0" rIns="0" bIns="0" rtlCol="0" anchor="ctr"/>
+          <a:lstStyle/>
+          <a:p>
+            <a:pPr algn="l" indent="0" marL="0">
+              <a:buNone/>
+            </a:pPr>
+            <a:r>
+              <a:rPr lang="en-US" sz="1200" b="1" spc="200" kern="0" dirty="0">
+                <a:solidFill>
+                  <a:srgbClr val="4FD8C4"/>
+                </a:solidFill>
+                <a:latin typeface="Calibri" pitchFamily="34" charset="0"/>
+                <a:ea typeface="Calibri" pitchFamily="34" charset="-122"/>
+                <a:cs typeface="Calibri" pitchFamily="34" charset="-120"/>
+              </a:rPr>
+              <a:t>VALIDACIÓN</a:t>
+            </a:r>
+            <a:endParaRPr lang="en-US" sz="1200" dirty="0"/>
+          </a:p>
+        </p:txBody>
+      </p:sp>
+      <p:sp>
+        <p:nvSpPr>
+          <p:cNvPr id="3" name="Text 1"/>
+          <p:cNvSpPr/>
+          <p:nvPr/>
+        </p:nvSpPr>
+        <p:spPr>
+          <a:xfrm>
+            <a:off x="640080" y="914400"/>
+            <a:ext cx="10881360" cy="1005840"/>
+          </a:xfrm>
+          <a:prstGeom prst="rect">
+            <a:avLst/>
+          </a:prstGeom>
+          <a:noFill/>
+          <a:ln/>
+        </p:spPr>
+        <p:txBody>
+          <a:bodyPr wrap="square" lIns="0" tIns="0" rIns="0" bIns="0" rtlCol="0" anchor="t"/>
+          <a:lstStyle/>
+          <a:p>
+            <a:pPr algn="l" indent="0" marL="0">
+              <a:lnSpc>
+                <a:spcPct val="100000"/>
+              </a:lnSpc>
+              <a:buNone/>
+            </a:pPr>
+            <a:r>
+              <a:rPr lang="en-US" sz="3400" b="1" dirty="0">
+                <a:solidFill>
+                  <a:srgbClr val="EAF2F5"/>
+                </a:solidFill>
+                <a:latin typeface="Cambria" pitchFamily="34" charset="0"/>
+                <a:ea typeface="Cambria" pitchFamily="34" charset="-122"/>
+                <a:cs typeface="Cambria" pitchFamily="34" charset="-120"/>
+              </a:rPr>
+              <a:t>Esto es ciencia de verdad, no humo</a:t>
+            </a:r>
+            <a:endParaRPr lang="en-US" sz="3400" dirty="0"/>
+          </a:p>
+        </p:txBody>
+      </p:sp>
+      <p:sp>
+        <p:nvSpPr>
+          <p:cNvPr id="4" name="Shape 2"/>
+          <p:cNvSpPr/>
+          <p:nvPr/>
+        </p:nvSpPr>
+        <p:spPr>
+          <a:xfrm>
+            <a:off x="640080" y="1828800"/>
+            <a:ext cx="3474720" cy="1920240"/>
+          </a:xfrm>
+          <a:prstGeom prst="roundRect">
+            <a:avLst>
+              <a:gd name="adj" fmla="val 5714"/>
+            </a:avLst>
+          </a:prstGeom>
+          <a:solidFill>
+            <a:srgbClr val="101F30"/>
+          </a:solidFill>
+          <a:ln w="12700">
+            <a:solidFill>
+              <a:srgbClr val="1D3348"/>
+            </a:solidFill>
+            <a:prstDash val="solid"/>
+          </a:ln>
+        </p:spPr>
+      </p:sp>
+      <p:sp>
+        <p:nvSpPr>
+          <p:cNvPr id="5" name="Text 3"/>
+          <p:cNvSpPr/>
+          <p:nvPr/>
+        </p:nvSpPr>
+        <p:spPr>
+          <a:xfrm>
+            <a:off x="914400" y="2057400"/>
+            <a:ext cx="2926080" cy="868680"/>
+          </a:xfrm>
+          <a:prstGeom prst="rect">
+            <a:avLst/>
+          </a:prstGeom>
+          <a:noFill/>
+          <a:ln/>
+        </p:spPr>
+        <p:txBody>
+          <a:bodyPr wrap="square" lIns="0" tIns="0" rIns="0" bIns="0" rtlCol="0" anchor="ctr"/>
+          <a:lstStyle/>
+          <a:p>
+            <a:pPr algn="l" indent="0" marL="0">
+              <a:buNone/>
+            </a:pPr>
+            <a:r>
+              <a:rPr lang="en-US" sz="4200" b="1" dirty="0">
+                <a:solidFill>
+                  <a:srgbClr val="4FD8C4"/>
+                </a:solidFill>
+                <a:latin typeface="Cambria" pitchFamily="34" charset="0"/>
+                <a:ea typeface="Cambria" pitchFamily="34" charset="-122"/>
+                <a:cs typeface="Cambria" pitchFamily="34" charset="-120"/>
+              </a:rPr>
+              <a:t>0.99</a:t>
+            </a:r>
+            <a:endParaRPr lang="en-US" sz="4200" dirty="0"/>
+          </a:p>
+        </p:txBody>
+      </p:sp>
+      <p:sp>
+        <p:nvSpPr>
+          <p:cNvPr id="6" name="Text 4"/>
+          <p:cNvSpPr/>
+          <p:nvPr/>
+        </p:nvSpPr>
+        <p:spPr>
+          <a:xfrm>
+            <a:off x="914400" y="2971800"/>
+            <a:ext cx="2926080" cy="685800"/>
+          </a:xfrm>
+          <a:prstGeom prst="rect">
+            <a:avLst/>
+          </a:prstGeom>
+          <a:noFill/>
+          <a:ln/>
+        </p:spPr>
+        <p:txBody>
+          <a:bodyPr wrap="square" lIns="0" tIns="0" rIns="0" bIns="0" rtlCol="0" anchor="ctr"/>
+          <a:lstStyle/>
+          <a:p>
+            <a:pPr algn="l" indent="0" marL="0">
+              <a:lnSpc>
+                <a:spcPct val="110000"/>
+              </a:lnSpc>
+              <a:buNone/>
+            </a:pPr>
+            <a:r>
+              <a:rPr lang="en-US" sz="1350" dirty="0">
+                <a:solidFill>
+                  <a:srgbClr val="8AA0B2"/>
+                </a:solidFill>
+                <a:latin typeface="Calibri" pitchFamily="34" charset="0"/>
+                <a:ea typeface="Calibri" pitchFamily="34" charset="-122"/>
+                <a:cs typeface="Calibri" pitchFamily="34" charset="-120"/>
+              </a:rPr>
+              <a:t>AUC de discriminación</a:t>
+            </a:r>
+            <a:endParaRPr lang="en-US" sz="1350" dirty="0"/>
+          </a:p>
+          <a:p>
+            <a:pPr algn="l" indent="0" marL="0">
+              <a:lnSpc>
+                <a:spcPct val="110000"/>
+              </a:lnSpc>
+              <a:buNone/>
+            </a:pPr>
+            <a:r>
+              <a:rPr lang="en-US" sz="1350" dirty="0">
+                <a:solidFill>
+                  <a:srgbClr val="8AA0B2"/>
+                </a:solidFill>
+                <a:latin typeface="Calibri" pitchFamily="34" charset="0"/>
+                <a:ea typeface="Calibri" pitchFamily="34" charset="-122"/>
+                <a:cs typeface="Calibri" pitchFamily="34" charset="-120"/>
+              </a:rPr>
+              <a:t>sobre datos reales (100k)</a:t>
+            </a:r>
+            <a:endParaRPr lang="en-US" sz="1350" dirty="0"/>
+          </a:p>
+        </p:txBody>
+      </p:sp>
+      <p:sp>
+        <p:nvSpPr>
+          <p:cNvPr id="7" name="Shape 5"/>
+          <p:cNvSpPr/>
+          <p:nvPr/>
+        </p:nvSpPr>
+        <p:spPr>
+          <a:xfrm>
+            <a:off x="4480560" y="1828800"/>
+            <a:ext cx="3474720" cy="1920240"/>
+          </a:xfrm>
+          <a:prstGeom prst="roundRect">
+            <a:avLst>
+              <a:gd name="adj" fmla="val 5714"/>
+            </a:avLst>
+          </a:prstGeom>
+          <a:solidFill>
+            <a:srgbClr val="101F30"/>
+          </a:solidFill>
+          <a:ln w="12700">
+            <a:solidFill>
+              <a:srgbClr val="1D3348"/>
+            </a:solidFill>
+            <a:prstDash val="solid"/>
+          </a:ln>
+        </p:spPr>
+      </p:sp>
+      <p:sp>
+        <p:nvSpPr>
+          <p:cNvPr id="8" name="Text 6"/>
+          <p:cNvSpPr/>
+          <p:nvPr/>
+        </p:nvSpPr>
+        <p:spPr>
+          <a:xfrm>
+            <a:off x="4754880" y="2057400"/>
+            <a:ext cx="2926080" cy="868680"/>
+          </a:xfrm>
+          <a:prstGeom prst="rect">
+            <a:avLst/>
+          </a:prstGeom>
+          <a:noFill/>
+          <a:ln/>
+        </p:spPr>
+        <p:txBody>
+          <a:bodyPr wrap="square" lIns="0" tIns="0" rIns="0" bIns="0" rtlCol="0" anchor="ctr"/>
+          <a:lstStyle/>
+          <a:p>
+            <a:pPr algn="l" indent="0" marL="0">
+              <a:buNone/>
+            </a:pPr>
+            <a:r>
+              <a:rPr lang="en-US" sz="4200" b="1" dirty="0">
+                <a:solidFill>
+                  <a:srgbClr val="9BA8F2"/>
+                </a:solidFill>
+                <a:latin typeface="Cambria" pitchFamily="34" charset="0"/>
+                <a:ea typeface="Cambria" pitchFamily="34" charset="-122"/>
+                <a:cs typeface="Cambria" pitchFamily="34" charset="-120"/>
+              </a:rPr>
+              <a:t>5-fold</a:t>
+            </a:r>
+            <a:endParaRPr lang="en-US" sz="4200" dirty="0"/>
+          </a:p>
+        </p:txBody>
+      </p:sp>
+      <p:sp>
+        <p:nvSpPr>
+          <p:cNvPr id="9" name="Text 7"/>
+          <p:cNvSpPr/>
+          <p:nvPr/>
+        </p:nvSpPr>
+        <p:spPr>
+          <a:xfrm>
+            <a:off x="4754880" y="2971800"/>
+            <a:ext cx="2926080" cy="685800"/>
+          </a:xfrm>
+          <a:prstGeom prst="rect">
+            <a:avLst/>
+          </a:prstGeom>
+          <a:noFill/>
+          <a:ln/>
+        </p:spPr>
+        <p:txBody>
+          <a:bodyPr wrap="square" lIns="0" tIns="0" rIns="0" bIns="0" rtlCol="0" anchor="ctr"/>
+          <a:lstStyle/>
+          <a:p>
+            <a:pPr algn="l" indent="0" marL="0">
+              <a:lnSpc>
+                <a:spcPct val="110000"/>
+              </a:lnSpc>
+              <a:buNone/>
+            </a:pPr>
+            <a:r>
+              <a:rPr lang="en-US" sz="1350" dirty="0">
+                <a:solidFill>
+                  <a:srgbClr val="8AA0B2"/>
+                </a:solidFill>
+                <a:latin typeface="Calibri" pitchFamily="34" charset="0"/>
+                <a:ea typeface="Calibri" pitchFamily="34" charset="-122"/>
+                <a:cs typeface="Calibri" pitchFamily="34" charset="-120"/>
+              </a:rPr>
+              <a:t>cross-validation</a:t>
+            </a:r>
+            <a:endParaRPr lang="en-US" sz="1350" dirty="0"/>
+          </a:p>
+          <a:p>
+            <a:pPr algn="l" indent="0" marL="0">
+              <a:lnSpc>
+                <a:spcPct val="110000"/>
+              </a:lnSpc>
+              <a:buNone/>
+            </a:pPr>
+            <a:r>
+              <a:rPr lang="en-US" sz="1350" dirty="0">
+                <a:solidFill>
+                  <a:srgbClr val="8AA0B2"/>
+                </a:solidFill>
+                <a:latin typeface="Calibri" pitchFamily="34" charset="0"/>
+                <a:ea typeface="Calibri" pitchFamily="34" charset="-122"/>
+                <a:cs typeface="Calibri" pitchFamily="34" charset="-120"/>
+              </a:rPr>
+              <a:t>estable, no suerte de un split</a:t>
+            </a:r>
+            <a:endParaRPr lang="en-US" sz="1350" dirty="0"/>
+          </a:p>
+        </p:txBody>
+      </p:sp>
+      <p:sp>
+        <p:nvSpPr>
+          <p:cNvPr id="10" name="Shape 8"/>
+          <p:cNvSpPr/>
+          <p:nvPr/>
+        </p:nvSpPr>
+        <p:spPr>
+          <a:xfrm>
+            <a:off x="8321040" y="1828800"/>
+            <a:ext cx="3474720" cy="1920240"/>
+          </a:xfrm>
+          <a:prstGeom prst="roundRect">
+            <a:avLst>
+              <a:gd name="adj" fmla="val 5714"/>
+            </a:avLst>
+          </a:prstGeom>
+          <a:solidFill>
+            <a:srgbClr val="101F30"/>
+          </a:solidFill>
+          <a:ln w="12700">
+            <a:solidFill>
+              <a:srgbClr val="1D3348"/>
+            </a:solidFill>
+            <a:prstDash val="solid"/>
+          </a:ln>
+        </p:spPr>
+      </p:sp>
+      <p:sp>
+        <p:nvSpPr>
+          <p:cNvPr id="11" name="Text 9"/>
+          <p:cNvSpPr/>
+          <p:nvPr/>
+        </p:nvSpPr>
+        <p:spPr>
+          <a:xfrm>
+            <a:off x="8595360" y="2057400"/>
+            <a:ext cx="2926080" cy="868680"/>
+          </a:xfrm>
+          <a:prstGeom prst="rect">
+            <a:avLst/>
+          </a:prstGeom>
+          <a:noFill/>
+          <a:ln/>
+        </p:spPr>
+        <p:txBody>
+          <a:bodyPr wrap="square" lIns="0" tIns="0" rIns="0" bIns="0" rtlCol="0" anchor="ctr"/>
+          <a:lstStyle/>
+          <a:p>
+            <a:pPr algn="l" indent="0" marL="0">
+              <a:buNone/>
+            </a:pPr>
+            <a:r>
+              <a:rPr lang="en-US" sz="4200" b="1" dirty="0">
+                <a:solidFill>
+                  <a:srgbClr val="F2B84B"/>
+                </a:solidFill>
+                <a:latin typeface="Cambria" pitchFamily="34" charset="0"/>
+                <a:ea typeface="Cambria" pitchFamily="34" charset="-122"/>
+                <a:cs typeface="Cambria" pitchFamily="34" charset="-120"/>
+              </a:rPr>
+              <a:t>Honestos</a:t>
+            </a:r>
+            <a:endParaRPr lang="en-US" sz="4200" dirty="0"/>
+          </a:p>
+        </p:txBody>
+      </p:sp>
+      <p:sp>
+        <p:nvSpPr>
+          <p:cNvPr id="12" name="Text 10"/>
+          <p:cNvSpPr/>
+          <p:nvPr/>
+        </p:nvSpPr>
+        <p:spPr>
+          <a:xfrm>
+            <a:off x="8595360" y="2971800"/>
+            <a:ext cx="2926080" cy="685800"/>
+          </a:xfrm>
+          <a:prstGeom prst="rect">
+            <a:avLst/>
+          </a:prstGeom>
+          <a:noFill/>
+          <a:ln/>
+        </p:spPr>
+        <p:txBody>
+          <a:bodyPr wrap="square" lIns="0" tIns="0" rIns="0" bIns="0" rtlCol="0" anchor="ctr"/>
+          <a:lstStyle/>
+          <a:p>
+            <a:pPr algn="l" indent="0" marL="0">
+              <a:lnSpc>
+                <a:spcPct val="110000"/>
+              </a:lnSpc>
+              <a:buNone/>
+            </a:pPr>
+            <a:r>
+              <a:rPr lang="en-US" sz="1350" dirty="0">
+                <a:solidFill>
+                  <a:srgbClr val="8AA0B2"/>
+                </a:solidFill>
+                <a:latin typeface="Calibri" pitchFamily="34" charset="0"/>
+                <a:ea typeface="Calibri" pitchFamily="34" charset="-122"/>
+                <a:cs typeface="Calibri" pitchFamily="34" charset="-120"/>
+              </a:rPr>
+              <a:t>mostramos la matriz de</a:t>
+            </a:r>
+            <a:endParaRPr lang="en-US" sz="1350" dirty="0"/>
+          </a:p>
+          <a:p>
+            <a:pPr algn="l" indent="0" marL="0">
+              <a:lnSpc>
+                <a:spcPct val="110000"/>
+              </a:lnSpc>
+              <a:buNone/>
+            </a:pPr>
+            <a:r>
+              <a:rPr lang="en-US" sz="1350" dirty="0">
+                <a:solidFill>
+                  <a:srgbClr val="8AA0B2"/>
+                </a:solidFill>
+                <a:latin typeface="Calibri" pitchFamily="34" charset="0"/>
+                <a:ea typeface="Calibri" pitchFamily="34" charset="-122"/>
+                <a:cs typeface="Calibri" pitchFamily="34" charset="-120"/>
+              </a:rPr>
+              <a:t>confusión, falsos positivos incluidos</a:t>
+            </a:r>
+            <a:endParaRPr lang="en-US" sz="1350" dirty="0"/>
+          </a:p>
+        </p:txBody>
+      </p:sp>
+      <p:pic>
+        <p:nvPicPr>
+          <p:cNvPr id="13" name="Image 0" descr="C:\Users\ecard\OneDrive\Escritorio\BIOPULSE PROYECTO CIENCIA DE DATOS\.worktrees\pitch\files\feature_importance_rf.png">    </p:cNvPr>
+          <p:cNvPicPr>
+            <a:picLocks noChangeAspect="1"/>
+          </p:cNvPicPr>
+          <p:nvPr/>
+        </p:nvPicPr>
+        <p:blipFill>
+          <a:blip r:embed="rId1"/>
+          <a:stretch>
+            <a:fillRect/>
+          </a:stretch>
+        </p:blipFill>
+        <p:spPr>
+          <a:xfrm>
+            <a:off x="640080" y="4023360"/>
+            <a:ext cx="3453003" cy="2423160"/>
+          </a:xfrm>
+          <a:prstGeom prst="rect">
+            <a:avLst/>
+          </a:prstGeom>
+        </p:spPr>
+      </p:pic>
+      <p:sp>
+        <p:nvSpPr>
+          <p:cNvPr id="14" name="Shape 11"/>
+          <p:cNvSpPr/>
+          <p:nvPr/>
+        </p:nvSpPr>
+        <p:spPr>
+          <a:xfrm>
+            <a:off x="4434840" y="4023360"/>
+            <a:ext cx="7086600" cy="2423160"/>
+          </a:xfrm>
+          <a:prstGeom prst="roundRect">
+            <a:avLst>
+              <a:gd name="adj" fmla="val 4528"/>
+            </a:avLst>
+          </a:prstGeom>
+          <a:solidFill>
+            <a:srgbClr val="0D1B2A"/>
+          </a:solidFill>
+          <a:ln w="12700">
+            <a:solidFill>
+              <a:srgbClr val="1D3348"/>
+            </a:solidFill>
+            <a:prstDash val="solid"/>
+          </a:ln>
+        </p:spPr>
+      </p:sp>
+      <p:sp>
+        <p:nvSpPr>
+          <p:cNvPr id="15" name="Text 12"/>
+          <p:cNvSpPr/>
+          <p:nvPr/>
+        </p:nvSpPr>
+        <p:spPr>
+          <a:xfrm>
+            <a:off x="4663440" y="4160520"/>
+            <a:ext cx="6629400" cy="2148840"/>
+          </a:xfrm>
+          <a:prstGeom prst="rect">
+            <a:avLst/>
+          </a:prstGeom>
+          <a:noFill/>
+          <a:ln/>
+        </p:spPr>
+        <p:txBody>
+          <a:bodyPr wrap="square" lIns="0" tIns="0" rIns="0" bIns="0" rtlCol="0" anchor="ctr"/>
+          <a:lstStyle/>
+          <a:p>
+            <a:pPr algn="l" indent="0" marL="0">
+              <a:buNone/>
+            </a:pPr>
+            <a:r>
+              <a:rPr lang="en-US" sz="1150" b="1" spc="100" kern="0" dirty="0">
+                <a:solidFill>
+                  <a:srgbClr val="4FD8C4"/>
+                </a:solidFill>
+                <a:latin typeface="Calibri" pitchFamily="34" charset="0"/>
+                <a:ea typeface="Calibri" pitchFamily="34" charset="-122"/>
+                <a:cs typeface="Calibri" pitchFamily="34" charset="-120"/>
+              </a:rPr>
+              <a:t>POR QUÉ CONFIAR  ·  </a:t>
+            </a:r>
+            <a:endParaRPr lang="en-US" sz="1150" dirty="0"/>
+          </a:p>
+          <a:p>
+            <a:pPr algn="l" indent="0" marL="0">
+              <a:lnSpc>
+                <a:spcPct val="125000"/>
+              </a:lnSpc>
+              <a:buNone/>
+            </a:pPr>
+            <a:r>
+              <a:rPr lang="en-US" sz="1400" dirty="0">
+                <a:solidFill>
+                  <a:srgbClr val="EAF2F5"/>
+                </a:solidFill>
+                <a:latin typeface="Calibri" pitchFamily="34" charset="0"/>
+                <a:ea typeface="Calibri" pitchFamily="34" charset="-122"/>
+                <a:cs typeface="Calibri" pitchFamily="34" charset="-120"/>
+              </a:rPr>
+              <a:t>El modelo aprendió solo que la temperatura de piel y la recuperación son las señales más predictivas — justo lo que dice la literatura clínica sobre infecciones y fatiga tempranas. La máquina coincide con los médicos.</a:t>
+            </a:r>
+            <a:endParaRPr lang="en-US" sz="1150" dirty="0"/>
+          </a:p>
+        </p:txBody>
+      </p:sp>
+      <p:sp>
+        <p:nvSpPr>
+          <p:cNvPr id="16" name="Text 13"/>
+          <p:cNvSpPr/>
+          <p:nvPr/>
+        </p:nvSpPr>
+        <p:spPr>
+          <a:xfrm>
+            <a:off x="640080" y="6473952"/>
+            <a:ext cx="7315200" cy="274320"/>
+          </a:xfrm>
+          <a:prstGeom prst="rect">
+            <a:avLst/>
+          </a:prstGeom>
+          <a:noFill/>
+          <a:ln/>
+        </p:spPr>
+        <p:txBody>
+          <a:bodyPr wrap="square" lIns="0" tIns="0" rIns="0" bIns="0" rtlCol="0" anchor="ctr"/>
+          <a:lstStyle/>
+          <a:p>
+            <a:pPr algn="l" indent="0" marL="0">
+              <a:buNone/>
+            </a:pPr>
+            <a:r>
+              <a:rPr lang="en-US" sz="900" dirty="0">
+                <a:solidFill>
+                  <a:srgbClr val="8AA0B2"/>
+                </a:solidFill>
+                <a:latin typeface="Calibri" pitchFamily="34" charset="0"/>
+                <a:ea typeface="Calibri" pitchFamily="34" charset="-122"/>
+                <a:cs typeface="Calibri" pitchFamily="34" charset="-120"/>
+              </a:rPr>
+              <a:t>BioPulse  ·  Predictive Biometric Analytics</a:t>
+            </a:r>
+            <a:endParaRPr lang="en-US" sz="900" dirty="0"/>
+          </a:p>
+        </p:txBody>
+      </p:sp>
+      <p:sp>
+        <p:nvSpPr>
+          <p:cNvPr id="17" name="Text 14"/>
+          <p:cNvSpPr/>
+          <p:nvPr/>
+        </p:nvSpPr>
+        <p:spPr>
+          <a:xfrm>
+            <a:off x="11155680" y="6473952"/>
+            <a:ext cx="548640" cy="274320"/>
+          </a:xfrm>
+          <a:prstGeom prst="rect">
+            <a:avLst/>
+          </a:prstGeom>
+          <a:noFill/>
+          <a:ln/>
+        </p:spPr>
+        <p:txBody>
+          <a:bodyPr wrap="square" lIns="0" tIns="0" rIns="0" bIns="0" rtlCol="0" anchor="ctr"/>
+          <a:lstStyle/>
+          <a:p>
+            <a:pPr algn="r" indent="0" marL="0">
+              <a:buNone/>
+            </a:pPr>
+            <a:r>
+              <a:rPr lang="en-US" sz="900" dirty="0">
+                <a:solidFill>
+                  <a:srgbClr val="8AA0B2"/>
+                </a:solidFill>
+                <a:latin typeface="Calibri" pitchFamily="34" charset="0"/>
+                <a:ea typeface="Calibri" pitchFamily="34" charset="-122"/>
+                <a:cs typeface="Calibri" pitchFamily="34" charset="-120"/>
+              </a:rPr>
+              <a:t>08</a:t>
+            </a:r>
+            <a:endParaRPr lang="en-US" sz="900" dirty="0"/>
+          </a:p>
+        </p:txBody>
+      </p:sp>
+    </p:spTree>
+  </p:cSld>
+  <p:clrMapOvr>
+    <a:masterClrMapping/>
+  </p:clrMapOvr>
+</p:sld>
+</file>
+
+<file path=ppt/slides/slide11.xml><?xml version="1.0" encoding="utf-8"?>
+<p:sld xmlns:a="http://schemas.openxmlformats.org/drawingml/2006/main" xmlns:r="http://schemas.openxmlformats.org/officeDocument/2006/relationships" xmlns:p="http://schemas.openxmlformats.org/presentationml/2006/main">
+  <p:cSld name="Slide 9">
+    <p:bg>
+      <p:bgPr>
+        <a:solidFill>
+          <a:srgbClr val="0A1420"/>
+        </a:solidFill>
+      </p:bgPr>
+    </p:bg>
+    <p:spTree>
+      <p:nvGrpSpPr>
+        <p:cNvPr id="1" name=""/>
+        <p:cNvGrpSpPr/>
+        <p:nvPr/>
+      </p:nvGrpSpPr>
+      <p:grpSpPr>
+        <a:xfrm>
+          <a:off x="0" y="0"/>
+          <a:ext cx="0" cy="0"/>
+          <a:chOff x="0" y="0"/>
+          <a:chExt cx="0" cy="0"/>
+        </a:xfrm>
+      </p:grpSpPr>
+      <p:sp>
+        <p:nvSpPr>
+          <p:cNvPr id="2" name="Text 0"/>
+          <p:cNvSpPr/>
+          <p:nvPr/>
+        </p:nvSpPr>
+        <p:spPr>
+          <a:xfrm>
+            <a:off x="640080" y="457200"/>
+            <a:ext cx="10881360" cy="274320"/>
+          </a:xfrm>
+          <a:prstGeom prst="rect">
+            <a:avLst/>
+          </a:prstGeom>
+          <a:noFill/>
+          <a:ln/>
+        </p:spPr>
+        <p:txBody>
+          <a:bodyPr wrap="square" lIns="0" tIns="0" rIns="0" bIns="0" rtlCol="0" anchor="ctr"/>
+          <a:lstStyle/>
+          <a:p>
+            <a:pPr algn="l" indent="0" marL="0">
+              <a:buNone/>
+            </a:pPr>
+            <a:r>
+              <a:rPr lang="en-US" sz="1200" b="1" spc="200" kern="0" dirty="0">
+                <a:solidFill>
+                  <a:srgbClr val="F2B84B"/>
+                </a:solidFill>
+                <a:latin typeface="Calibri" pitchFamily="34" charset="0"/>
+                <a:ea typeface="Calibri" pitchFamily="34" charset="-122"/>
+                <a:cs typeface="Calibri" pitchFamily="34" charset="-120"/>
+              </a:rPr>
+              <a:t>MERCADO</a:t>
+            </a:r>
+            <a:endParaRPr lang="en-US" sz="1200" dirty="0"/>
+          </a:p>
+        </p:txBody>
+      </p:sp>
+      <p:sp>
+        <p:nvSpPr>
+          <p:cNvPr id="3" name="Text 1"/>
+          <p:cNvSpPr/>
+          <p:nvPr/>
+        </p:nvSpPr>
+        <p:spPr>
+          <a:xfrm>
+            <a:off x="640080" y="914400"/>
+            <a:ext cx="10881360" cy="1005840"/>
+          </a:xfrm>
+          <a:prstGeom prst="rect">
+            <a:avLst/>
+          </a:prstGeom>
+          <a:noFill/>
+          <a:ln/>
+        </p:spPr>
+        <p:txBody>
+          <a:bodyPr wrap="square" lIns="0" tIns="0" rIns="0" bIns="0" rtlCol="0" anchor="t"/>
+          <a:lstStyle/>
+          <a:p>
+            <a:pPr algn="l" indent="0" marL="0">
+              <a:lnSpc>
+                <a:spcPct val="100000"/>
+              </a:lnSpc>
+              <a:buNone/>
+            </a:pPr>
+            <a:r>
+              <a:rPr lang="en-US" sz="3400" b="1" dirty="0">
+                <a:solidFill>
+                  <a:srgbClr val="EAF2F5"/>
+                </a:solidFill>
+                <a:latin typeface="Cambria" pitchFamily="34" charset="0"/>
+                <a:ea typeface="Cambria" pitchFamily="34" charset="-122"/>
+                <a:cs typeface="Cambria" pitchFamily="34" charset="-120"/>
+              </a:rPr>
+              <a:t>Una ventana abierta, justo ahora</a:t>
+            </a:r>
+            <a:endParaRPr lang="en-US" sz="3400" dirty="0"/>
+          </a:p>
+        </p:txBody>
+      </p:sp>
+      <p:sp>
+        <p:nvSpPr>
+          <p:cNvPr id="4" name="Shape 2"/>
+          <p:cNvSpPr/>
+          <p:nvPr/>
+        </p:nvSpPr>
+        <p:spPr>
+          <a:xfrm>
+            <a:off x="640080" y="1828800"/>
+            <a:ext cx="3474720" cy="2834640"/>
+          </a:xfrm>
+          <a:prstGeom prst="roundRect">
+            <a:avLst>
+              <a:gd name="adj" fmla="val 3871"/>
+            </a:avLst>
+          </a:prstGeom>
+          <a:solidFill>
+            <a:srgbClr val="101F30"/>
+          </a:solidFill>
+          <a:ln w="12700">
+            <a:solidFill>
+              <a:srgbClr val="4FD8C4"/>
+            </a:solidFill>
+            <a:prstDash val="solid"/>
+          </a:ln>
+        </p:spPr>
+      </p:sp>
+      <p:sp>
+        <p:nvSpPr>
+          <p:cNvPr id="5" name="Shape 3"/>
+          <p:cNvSpPr/>
+          <p:nvPr/>
+        </p:nvSpPr>
+        <p:spPr>
+          <a:xfrm>
+            <a:off x="914400" y="2148840"/>
+            <a:ext cx="548640" cy="548640"/>
+          </a:xfrm>
+          <a:prstGeom prst="ellipse">
+            <a:avLst/>
+          </a:prstGeom>
+          <a:solidFill>
+            <a:srgbClr val="4FD8C4"/>
+          </a:solidFill>
+          <a:ln/>
+        </p:spPr>
+      </p:sp>
+      <p:sp>
+        <p:nvSpPr>
+          <p:cNvPr id="6" name="Text 4"/>
+          <p:cNvSpPr/>
+          <p:nvPr/>
+        </p:nvSpPr>
+        <p:spPr>
+          <a:xfrm>
+            <a:off x="1600200" y="2148840"/>
+            <a:ext cx="2286000" cy="548640"/>
+          </a:xfrm>
+          <a:prstGeom prst="rect">
+            <a:avLst/>
+          </a:prstGeom>
+          <a:noFill/>
+          <a:ln/>
+        </p:spPr>
+        <p:txBody>
+          <a:bodyPr wrap="square" lIns="0" tIns="0" rIns="0" bIns="0" rtlCol="0" anchor="ctr"/>
+          <a:lstStyle/>
+          <a:p>
+            <a:pPr indent="0" marL="0">
+              <a:buNone/>
+            </a:pPr>
+            <a:r>
+              <a:rPr lang="en-US" sz="1500" b="1" dirty="0">
+                <a:solidFill>
+                  <a:srgbClr val="EAF2F5"/>
+                </a:solidFill>
+                <a:latin typeface="Cambria" pitchFamily="34" charset="0"/>
+                <a:ea typeface="Cambria" pitchFamily="34" charset="-122"/>
+                <a:cs typeface="Cambria" pitchFamily="34" charset="-120"/>
+              </a:rPr>
+              <a:t>Wearables en auge</a:t>
+            </a:r>
+            <a:endParaRPr lang="en-US" sz="1500" dirty="0"/>
+          </a:p>
+        </p:txBody>
+      </p:sp>
+      <p:sp>
+        <p:nvSpPr>
+          <p:cNvPr id="7" name="Text 5"/>
+          <p:cNvSpPr/>
+          <p:nvPr/>
+        </p:nvSpPr>
+        <p:spPr>
+          <a:xfrm>
+            <a:off x="914400" y="2971800"/>
+            <a:ext cx="2926080" cy="1554480"/>
+          </a:xfrm>
+          <a:prstGeom prst="rect">
+            <a:avLst/>
+          </a:prstGeom>
+          <a:noFill/>
+          <a:ln/>
+        </p:spPr>
+        <p:txBody>
+          <a:bodyPr wrap="square" lIns="0" tIns="0" rIns="0" bIns="0" rtlCol="0" anchor="ctr"/>
+          <a:lstStyle/>
+          <a:p>
+            <a:pPr algn="l" indent="0" marL="0">
+              <a:lnSpc>
+                <a:spcPct val="125000"/>
+              </a:lnSpc>
+              <a:buNone/>
+            </a:pPr>
+            <a:r>
+              <a:rPr lang="en-US" sz="1350" dirty="0">
+                <a:solidFill>
+                  <a:srgbClr val="8AA0B2"/>
+                </a:solidFill>
+                <a:latin typeface="Calibri" pitchFamily="34" charset="0"/>
+                <a:ea typeface="Calibri" pitchFamily="34" charset="-122"/>
+                <a:cs typeface="Calibri" pitchFamily="34" charset="-120"/>
+              </a:rPr>
+              <a:t>Cada vez más relojes y pulseras inteligentes en muñecas; la demanda de “más que pasos” crece.</a:t>
+            </a:r>
+            <a:endParaRPr lang="en-US" sz="1350" dirty="0"/>
+          </a:p>
+        </p:txBody>
+      </p:sp>
+      <p:sp>
+        <p:nvSpPr>
+          <p:cNvPr id="8" name="Shape 6"/>
+          <p:cNvSpPr/>
+          <p:nvPr/>
+        </p:nvSpPr>
+        <p:spPr>
+          <a:xfrm>
+            <a:off x="4480560" y="1828800"/>
+            <a:ext cx="3474720" cy="2834640"/>
+          </a:xfrm>
+          <a:prstGeom prst="roundRect">
+            <a:avLst>
+              <a:gd name="adj" fmla="val 3871"/>
+            </a:avLst>
+          </a:prstGeom>
+          <a:solidFill>
+            <a:srgbClr val="101F30"/>
+          </a:solidFill>
+          <a:ln w="12700">
+            <a:solidFill>
+              <a:srgbClr val="F0687A"/>
+            </a:solidFill>
+            <a:prstDash val="solid"/>
+          </a:ln>
+        </p:spPr>
+      </p:sp>
+      <p:sp>
+        <p:nvSpPr>
+          <p:cNvPr id="9" name="Shape 7"/>
+          <p:cNvSpPr/>
+          <p:nvPr/>
+        </p:nvSpPr>
+        <p:spPr>
+          <a:xfrm>
+            <a:off x="4754880" y="2148840"/>
+            <a:ext cx="548640" cy="548640"/>
+          </a:xfrm>
+          <a:prstGeom prst="ellipse">
+            <a:avLst/>
+          </a:prstGeom>
+          <a:solidFill>
+            <a:srgbClr val="F0687A"/>
+          </a:solidFill>
+          <a:ln/>
+        </p:spPr>
+      </p:sp>
+      <p:sp>
+        <p:nvSpPr>
+          <p:cNvPr id="10" name="Text 8"/>
+          <p:cNvSpPr/>
+          <p:nvPr/>
+        </p:nvSpPr>
+        <p:spPr>
+          <a:xfrm>
+            <a:off x="5440680" y="2148840"/>
+            <a:ext cx="2286000" cy="548640"/>
+          </a:xfrm>
+          <a:prstGeom prst="rect">
+            <a:avLst/>
+          </a:prstGeom>
+          <a:noFill/>
+          <a:ln/>
+        </p:spPr>
+        <p:txBody>
+          <a:bodyPr wrap="square" lIns="0" tIns="0" rIns="0" bIns="0" rtlCol="0" anchor="ctr"/>
+          <a:lstStyle/>
+          <a:p>
+            <a:pPr indent="0" marL="0">
+              <a:buNone/>
+            </a:pPr>
+            <a:r>
+              <a:rPr lang="en-US" sz="1500" b="1" dirty="0">
+                <a:solidFill>
+                  <a:srgbClr val="EAF2F5"/>
+                </a:solidFill>
+                <a:latin typeface="Cambria" pitchFamily="34" charset="0"/>
+                <a:ea typeface="Cambria" pitchFamily="34" charset="-122"/>
+                <a:cs typeface="Cambria" pitchFamily="34" charset="-120"/>
+              </a:rPr>
+              <a:t>Población que envejece</a:t>
+            </a:r>
+            <a:endParaRPr lang="en-US" sz="1500" dirty="0"/>
+          </a:p>
+        </p:txBody>
+      </p:sp>
+      <p:sp>
+        <p:nvSpPr>
+          <p:cNvPr id="11" name="Text 9"/>
+          <p:cNvSpPr/>
+          <p:nvPr/>
+        </p:nvSpPr>
+        <p:spPr>
+          <a:xfrm>
+            <a:off x="4754880" y="2971800"/>
+            <a:ext cx="2926080" cy="1554480"/>
+          </a:xfrm>
+          <a:prstGeom prst="rect">
+            <a:avLst/>
+          </a:prstGeom>
+          <a:noFill/>
+          <a:ln/>
+        </p:spPr>
+        <p:txBody>
+          <a:bodyPr wrap="square" lIns="0" tIns="0" rIns="0" bIns="0" rtlCol="0" anchor="ctr"/>
+          <a:lstStyle/>
+          <a:p>
+            <a:pPr algn="l" indent="0" marL="0">
+              <a:lnSpc>
+                <a:spcPct val="125000"/>
+              </a:lnSpc>
+              <a:buNone/>
+            </a:pPr>
+            <a:r>
+              <a:rPr lang="en-US" sz="1350" dirty="0">
+                <a:solidFill>
+                  <a:srgbClr val="8AA0B2"/>
+                </a:solidFill>
+                <a:latin typeface="Calibri" pitchFamily="34" charset="0"/>
+                <a:ea typeface="Calibri" pitchFamily="34" charset="-122"/>
+                <a:cs typeface="Calibri" pitchFamily="34" charset="-120"/>
+              </a:rPr>
+              <a:t>Más adultos mayores, más caídas e infecciones prevenibles que el sistema no detecta a tiempo.</a:t>
+            </a:r>
+            <a:endParaRPr lang="en-US" sz="1350" dirty="0"/>
+          </a:p>
+        </p:txBody>
+      </p:sp>
+      <p:sp>
+        <p:nvSpPr>
+          <p:cNvPr id="12" name="Shape 10"/>
+          <p:cNvSpPr/>
+          <p:nvPr/>
+        </p:nvSpPr>
+        <p:spPr>
+          <a:xfrm>
+            <a:off x="8321040" y="1828800"/>
+            <a:ext cx="3474720" cy="2834640"/>
+          </a:xfrm>
+          <a:prstGeom prst="roundRect">
+            <a:avLst>
+              <a:gd name="adj" fmla="val 3871"/>
+            </a:avLst>
+          </a:prstGeom>
+          <a:solidFill>
+            <a:srgbClr val="101F30"/>
+          </a:solidFill>
+          <a:ln w="12700">
+            <a:solidFill>
+              <a:srgbClr val="9BA8F2"/>
+            </a:solidFill>
+            <a:prstDash val="solid"/>
+          </a:ln>
+        </p:spPr>
+      </p:sp>
+      <p:sp>
+        <p:nvSpPr>
+          <p:cNvPr id="13" name="Shape 11"/>
+          <p:cNvSpPr/>
+          <p:nvPr/>
+        </p:nvSpPr>
+        <p:spPr>
+          <a:xfrm>
+            <a:off x="8595360" y="2148840"/>
+            <a:ext cx="548640" cy="548640"/>
+          </a:xfrm>
+          <a:prstGeom prst="ellipse">
+            <a:avLst/>
+          </a:prstGeom>
+          <a:solidFill>
+            <a:srgbClr val="9BA8F2"/>
+          </a:solidFill>
+          <a:ln/>
+        </p:spPr>
+      </p:sp>
+      <p:sp>
+        <p:nvSpPr>
+          <p:cNvPr id="14" name="Text 12"/>
+          <p:cNvSpPr/>
+          <p:nvPr/>
+        </p:nvSpPr>
+        <p:spPr>
+          <a:xfrm>
+            <a:off x="9281160" y="2148840"/>
+            <a:ext cx="2286000" cy="548640"/>
+          </a:xfrm>
+          <a:prstGeom prst="rect">
+            <a:avLst/>
+          </a:prstGeom>
+          <a:noFill/>
+          <a:ln/>
+        </p:spPr>
+        <p:txBody>
+          <a:bodyPr wrap="square" lIns="0" tIns="0" rIns="0" bIns="0" rtlCol="0" anchor="ctr"/>
+          <a:lstStyle/>
+          <a:p>
+            <a:pPr indent="0" marL="0">
+              <a:buNone/>
+            </a:pPr>
+            <a:r>
+              <a:rPr lang="en-US" sz="1500" b="1" dirty="0">
+                <a:solidFill>
+                  <a:srgbClr val="EAF2F5"/>
+                </a:solidFill>
+                <a:latin typeface="Cambria" pitchFamily="34" charset="0"/>
+                <a:ea typeface="Cambria" pitchFamily="34" charset="-122"/>
+                <a:cs typeface="Cambria" pitchFamily="34" charset="-120"/>
+              </a:rPr>
+              <a:t>El cuello de botella</a:t>
+            </a:r>
+            <a:endParaRPr lang="en-US" sz="1500" dirty="0"/>
+          </a:p>
+        </p:txBody>
+      </p:sp>
+      <p:sp>
+        <p:nvSpPr>
+          <p:cNvPr id="15" name="Text 13"/>
+          <p:cNvSpPr/>
+          <p:nvPr/>
+        </p:nvSpPr>
+        <p:spPr>
+          <a:xfrm>
+            <a:off x="8595360" y="2971800"/>
+            <a:ext cx="2926080" cy="1554480"/>
+          </a:xfrm>
+          <a:prstGeom prst="rect">
+            <a:avLst/>
+          </a:prstGeom>
+          <a:noFill/>
+          <a:ln/>
+        </p:spPr>
+        <p:txBody>
+          <a:bodyPr wrap="square" lIns="0" tIns="0" rIns="0" bIns="0" rtlCol="0" anchor="ctr"/>
+          <a:lstStyle/>
+          <a:p>
+            <a:pPr algn="l" indent="0" marL="0">
+              <a:lnSpc>
+                <a:spcPct val="125000"/>
+              </a:lnSpc>
+              <a:buNone/>
+            </a:pPr>
+            <a:r>
+              <a:rPr lang="en-US" sz="1350" dirty="0">
+                <a:solidFill>
+                  <a:srgbClr val="8AA0B2"/>
+                </a:solidFill>
+                <a:latin typeface="Calibri" pitchFamily="34" charset="0"/>
+                <a:ea typeface="Calibri" pitchFamily="34" charset="-122"/>
+                <a:cs typeface="Calibri" pitchFamily="34" charset="-120"/>
+              </a:rPr>
+              <a:t>La capa de IA predictiva de salud está vacía. El hardware existe; la inteligencia no.</a:t>
+            </a:r>
+            <a:endParaRPr lang="en-US" sz="1350" dirty="0"/>
+          </a:p>
+        </p:txBody>
+      </p:sp>
+      <p:sp>
+        <p:nvSpPr>
+          <p:cNvPr id="16" name="Text 14"/>
+          <p:cNvSpPr/>
+          <p:nvPr/>
+        </p:nvSpPr>
+        <p:spPr>
+          <a:xfrm>
+            <a:off x="640080" y="4937760"/>
+            <a:ext cx="11064240" cy="1005840"/>
+          </a:xfrm>
+          <a:prstGeom prst="rect">
+            <a:avLst/>
+          </a:prstGeom>
+          <a:noFill/>
+          <a:ln/>
+        </p:spPr>
+        <p:txBody>
+          <a:bodyPr wrap="square" lIns="0" tIns="0" rIns="0" bIns="0" rtlCol="0" anchor="ctr"/>
+          <a:lstStyle/>
+          <a:p>
+            <a:pPr algn="l" indent="0" marL="0">
+              <a:lnSpc>
+                <a:spcPct val="120000"/>
+              </a:lnSpc>
+              <a:buNone/>
+            </a:pPr>
+            <a:r>
+              <a:rPr lang="en-US" sz="1600" i="1" dirty="0">
+                <a:solidFill>
+                  <a:srgbClr val="EAF2F5"/>
+                </a:solidFill>
+                <a:latin typeface="Calibri" pitchFamily="34" charset="0"/>
+                <a:ea typeface="Calibri" pitchFamily="34" charset="-122"/>
+                <a:cs typeface="Calibri" pitchFamily="34" charset="-120"/>
+              </a:rPr>
+              <a:t>El hardware ya está en la muñeca de millones. Solo falta la capa que convierta esos datos en cuidado. Esa capa somos nosotros.</a:t>
+            </a:r>
+            <a:endParaRPr lang="en-US" sz="1600" dirty="0"/>
+          </a:p>
+        </p:txBody>
+      </p:sp>
+      <p:sp>
+        <p:nvSpPr>
+          <p:cNvPr id="17" name="Text 15"/>
+          <p:cNvSpPr/>
+          <p:nvPr/>
+        </p:nvSpPr>
+        <p:spPr>
+          <a:xfrm>
+            <a:off x="640080" y="6473952"/>
+            <a:ext cx="7315200" cy="274320"/>
+          </a:xfrm>
+          <a:prstGeom prst="rect">
+            <a:avLst/>
+          </a:prstGeom>
+          <a:noFill/>
+          <a:ln/>
+        </p:spPr>
+        <p:txBody>
+          <a:bodyPr wrap="square" lIns="0" tIns="0" rIns="0" bIns="0" rtlCol="0" anchor="ctr"/>
+          <a:lstStyle/>
+          <a:p>
+            <a:pPr algn="l" indent="0" marL="0">
+              <a:buNone/>
+            </a:pPr>
+            <a:r>
+              <a:rPr lang="en-US" sz="900" dirty="0">
+                <a:solidFill>
+                  <a:srgbClr val="8AA0B2"/>
+                </a:solidFill>
+                <a:latin typeface="Calibri" pitchFamily="34" charset="0"/>
+                <a:ea typeface="Calibri" pitchFamily="34" charset="-122"/>
+                <a:cs typeface="Calibri" pitchFamily="34" charset="-120"/>
+              </a:rPr>
+              <a:t>BioPulse  ·  Predictive Biometric Analytics</a:t>
+            </a:r>
+            <a:endParaRPr lang="en-US" sz="900" dirty="0"/>
+          </a:p>
+        </p:txBody>
+      </p:sp>
+      <p:sp>
+        <p:nvSpPr>
+          <p:cNvPr id="18" name="Text 16"/>
+          <p:cNvSpPr/>
+          <p:nvPr/>
+        </p:nvSpPr>
+        <p:spPr>
+          <a:xfrm>
+            <a:off x="11155680" y="6473952"/>
+            <a:ext cx="548640" cy="274320"/>
+          </a:xfrm>
+          <a:prstGeom prst="rect">
+            <a:avLst/>
+          </a:prstGeom>
+          <a:noFill/>
+          <a:ln/>
+        </p:spPr>
+        <p:txBody>
+          <a:bodyPr wrap="square" lIns="0" tIns="0" rIns="0" bIns="0" rtlCol="0" anchor="ctr"/>
+          <a:lstStyle/>
+          <a:p>
+            <a:pPr algn="r" indent="0" marL="0">
+              <a:buNone/>
+            </a:pPr>
+            <a:r>
+              <a:rPr lang="en-US" sz="900" dirty="0">
+                <a:solidFill>
+                  <a:srgbClr val="8AA0B2"/>
+                </a:solidFill>
+                <a:latin typeface="Calibri" pitchFamily="34" charset="0"/>
+                <a:ea typeface="Calibri" pitchFamily="34" charset="-122"/>
+                <a:cs typeface="Calibri" pitchFamily="34" charset="-120"/>
+              </a:rPr>
+              <a:t>09</a:t>
+            </a:r>
+            <a:endParaRPr lang="en-US" sz="900" dirty="0"/>
+          </a:p>
+        </p:txBody>
+      </p:sp>
+    </p:spTree>
+  </p:cSld>
+  <p:clrMapOvr>
+    <a:masterClrMapping/>
+  </p:clrMapOvr>
+</p:sld>
+</file>
+
+<file path=ppt/slides/slide12.xml><?xml version="1.0" encoding="utf-8"?>
+<p:sld xmlns:a="http://schemas.openxmlformats.org/drawingml/2006/main" xmlns:r="http://schemas.openxmlformats.org/officeDocument/2006/relationships" xmlns:p="http://schemas.openxmlformats.org/presentationml/2006/main">
   <p:cSld name="Slide 10">
     <p:bg>
       <p:bgPr>
@@ -2840,7 +4144,7 @@
 </p:sld>
 </file>
 
-<file path=ppt/slides/slide11.xml><?xml version="1.0" encoding="utf-8"?>
+<file path=ppt/slides/slide13.xml><?xml version="1.0" encoding="utf-8"?>
 <p:sld xmlns:a="http://schemas.openxmlformats.org/drawingml/2006/main" xmlns:r="http://schemas.openxmlformats.org/officeDocument/2006/relationships" xmlns:p="http://schemas.openxmlformats.org/presentationml/2006/main">
   <p:cSld name="Slide 11">
     <p:bg>
@@ -5050,6 +6354,10 @@
           </a:solidFill>
           <a:ln/>
         </p:spPr>
+        <p:txBody>
+          <a:bodyPr/>
+          <a:p/>
+        </p:txBody>
       </p:sp>
       <p:sp>
         <p:nvSpPr>
@@ -5091,6 +6399,46 @@
             </a:r>
             <a:endParaRPr lang="en-US" sz="1400" dirty="0"/>
           </a:p>
+          <a:p>
+            <a:r>
+              <a:rPr sz="1300">
+                <a:solidFill>
+                  <a:srgbClr val="8AA0B2"/>
+                </a:solidFill>
+              </a:rPr>
+              <a:t>BioScore y Sleep Score: bienestar y sueño en un vistazo (mayor = mejor)</a:t>
+            </a:r>
+          </a:p>
+          <a:p>
+            <a:r>
+              <a:rPr sz="1300">
+                <a:solidFill>
+                  <a:srgbClr val="8AA0B2"/>
+                </a:solidFill>
+              </a:rPr>
+              <a:t>Coach con Plan de hoy: 3 pasos accionables si el riesgo sube</a:t>
+            </a:r>
+          </a:p>
+          <a:p>
+            <a:r>
+              <a:rPr sz="1300">
+                <a:solidFill>
+                  <a:srgbClr val="8AA0B2"/>
+                </a:solidFill>
+              </a:rPr>
+              <a:t>Respiración guiada de 2 min para calmarte al instante</a:t>
+            </a:r>
+          </a:p>
+          <a:p>
+            <a:r>
+              <a:rPr sz="1300">
+                <a:solidFill>
+                  <a:srgbClr val="8AA0B2"/>
+                </a:solidFill>
+              </a:rPr>
+              <a:t>Diseño de vidrio iOS 26, modo claro/oscuro al instante</a:t>
+            </a:r>
+          </a:p>
         </p:txBody>
       </p:sp>
       <p:sp>
@@ -5112,6 +6460,10 @@
           </a:solidFill>
           <a:ln/>
         </p:spPr>
+        <p:txBody>
+          <a:bodyPr/>
+          <a:p/>
+        </p:txBody>
       </p:sp>
       <p:sp>
         <p:nvSpPr>
@@ -5174,6 +6526,10 @@
           </a:solidFill>
           <a:ln/>
         </p:spPr>
+        <p:txBody>
+          <a:bodyPr/>
+          <a:p/>
+        </p:txBody>
       </p:sp>
       <p:sp>
         <p:nvSpPr>
@@ -5236,6 +6592,10 @@
           </a:solidFill>
           <a:ln/>
         </p:spPr>
+        <p:txBody>
+          <a:bodyPr/>
+          <a:p/>
+        </p:txBody>
       </p:sp>
       <p:sp>
         <p:nvSpPr>
@@ -5305,6 +6665,10 @@
             <a:prstDash val="solid"/>
           </a:ln>
         </p:spPr>
+        <p:txBody>
+          <a:bodyPr/>
+          <a:p/>
+        </p:txBody>
       </p:sp>
       <p:sp>
         <p:nvSpPr>
@@ -5325,6 +6689,10 @@
           </a:solidFill>
           <a:ln/>
         </p:spPr>
+        <p:txBody>
+          <a:bodyPr/>
+          <a:p/>
+        </p:txBody>
       </p:sp>
       <p:sp>
         <p:nvSpPr>
@@ -5425,6 +6793,10 @@
             <a:prstDash val="solid"/>
           </a:ln>
         </p:spPr>
+        <p:txBody>
+          <a:bodyPr/>
+          <a:p/>
+        </p:txBody>
       </p:sp>
       <p:sp>
         <p:nvSpPr>
@@ -5447,6 +6819,10 @@
             <a:prstDash val="solid"/>
           </a:ln>
         </p:spPr>
+        <p:txBody>
+          <a:bodyPr/>
+          <a:p/>
+        </p:txBody>
       </p:sp>
       <p:sp>
         <p:nvSpPr>
@@ -6396,6 +7772,10 @@
             <a:prstDash val="solid"/>
           </a:ln>
         </p:spPr>
+        <p:txBody>
+          <a:bodyPr/>
+          <a:p/>
+        </p:txBody>
       </p:sp>
       <p:sp>
         <p:nvSpPr>
@@ -6495,6 +7875,16 @@
               <a:t>sobre datos reales</a:t>
             </a:r>
             <a:endParaRPr lang="en-US" sz="1400" dirty="0"/>
+          </a:p>
+          <a:p>
+            <a:r>
+              <a:rPr sz="1300">
+                <a:solidFill>
+                  <a:srgbClr val="8AA0B2"/>
+                </a:solidFill>
+              </a:rPr>
+              <a:t>10 datasets de wearable realistas (30 días cada uno) ya integrados</a:t>
+            </a:r>
           </a:p>
         </p:txBody>
       </p:sp>
@@ -6524,6 +7914,10 @@
             <a:prstDash val="solid"/>
           </a:ln>
         </p:spPr>
+        <p:txBody>
+          <a:bodyPr/>
+          <a:p/>
+        </p:txBody>
       </p:sp>
       <p:sp>
         <p:nvSpPr>
@@ -6652,6 +8046,10 @@
             <a:prstDash val="solid"/>
           </a:ln>
         </p:spPr>
+        <p:txBody>
+          <a:bodyPr/>
+          <a:p/>
+        </p:txBody>
       </p:sp>
       <p:sp>
         <p:nvSpPr>
@@ -6780,6 +8178,10 @@
             <a:prstDash val="solid"/>
           </a:ln>
         </p:spPr>
+        <p:txBody>
+          <a:bodyPr/>
+          <a:p/>
+        </p:txBody>
       </p:sp>
       <p:sp>
         <p:nvSpPr>
@@ -7699,29 +9101,15 @@
 </file>
 
 <file path=ppt/slides/slide8.xml><?xml version="1.0" encoding="utf-8"?>
-<p:sld xmlns:a="http://schemas.openxmlformats.org/drawingml/2006/main" xmlns:r="http://schemas.openxmlformats.org/officeDocument/2006/relationships" xmlns:p="http://schemas.openxmlformats.org/presentationml/2006/main">
-  <p:cSld name="Slide 8">
-    <p:bg>
-      <p:bgPr>
-        <a:solidFill>
-          <a:srgbClr val="0A1420"/>
-        </a:solidFill>
-      </p:bgPr>
-    </p:bg>
+<p:sld xmlns:a="http://schemas.openxmlformats.org/drawingml/2006/main" xmlns:p="http://schemas.openxmlformats.org/presentationml/2006/main" xmlns:r="http://schemas.openxmlformats.org/officeDocument/2006/relationships">
+  <p:cSld>
     <p:spTree>
       <p:nvGrpSpPr>
         <p:cNvPr id="1" name=""/>
         <p:cNvGrpSpPr/>
         <p:nvPr/>
       </p:nvGrpSpPr>
-      <p:grpSpPr>
-        <a:xfrm>
-          <a:off x="0" y="0"/>
-          <a:ext cx="0" cy="0"/>
-          <a:chOff x="0" y="0"/>
-          <a:chExt cx="0" cy="0"/>
-        </a:xfrm>
-      </p:grpSpPr>
+      <p:grpSpPr/>
       <p:sp>
         <p:nvSpPr>
           <p:cNvPr id="2" name="Text 0"/>
@@ -7755,7 +9143,7 @@
                 <a:ea typeface="Calibri" pitchFamily="34" charset="-122"/>
                 <a:cs typeface="Calibri" pitchFamily="34" charset="-120"/>
               </a:rPr>
-              <a:t>VALIDACIÓN</a:t>
+              <a:t>TU LABORATORIO</a:t>
             </a:r>
             <a:endParaRPr lang="en-US" sz="1200" dirty="0"/>
           </a:p>
@@ -7797,7 +9185,7 @@
                 <a:ea typeface="Cambria" pitchFamily="34" charset="-122"/>
                 <a:cs typeface="Cambria" pitchFamily="34" charset="-120"/>
               </a:rPr>
-              <a:t>Esto es ciencia de verdad, no humo</a:t>
+              <a:t>Predicciones personales desde tus métricas</a:t>
             </a:r>
             <a:endParaRPr lang="en-US" sz="3400" dirty="0"/>
           </a:p>
@@ -7811,12 +9199,85 @@
         </p:nvSpPr>
         <p:spPr>
           <a:xfrm>
-            <a:off x="640080" y="1828800"/>
-            <a:ext cx="3474720" cy="1920240"/>
+            <a:off x="640080" y="1920240"/>
+            <a:ext cx="10881360" cy="1828800"/>
           </a:xfrm>
           <a:prstGeom prst="roundRect">
             <a:avLst>
-              <a:gd name="adj" fmla="val 5714"/>
+              <a:gd name="adj" fmla="val 6000"/>
+            </a:avLst>
+          </a:prstGeom>
+          <a:solidFill>
+            <a:srgbClr val="0D1B2A"/>
+          </a:solidFill>
+          <a:ln w="12700">
+            <a:solidFill>
+              <a:srgbClr val="4FD8C4"/>
+            </a:solidFill>
+            <a:prstDash val="solid"/>
+          </a:ln>
+        </p:spPr>
+        <p:txBody>
+          <a:bodyPr/>
+          <a:p/>
+        </p:txBody>
+      </p:sp>
+      <p:sp>
+        <p:nvSpPr>
+          <p:cNvPr id="5" name="Text 3"/>
+          <p:cNvSpPr/>
+          <p:nvPr/>
+        </p:nvSpPr>
+        <p:spPr>
+          <a:xfrm>
+            <a:off x="914400" y="2103120"/>
+            <a:ext cx="10332720" cy="1463040"/>
+          </a:xfrm>
+          <a:prstGeom prst="rect">
+            <a:avLst/>
+          </a:prstGeom>
+          <a:noFill/>
+          <a:ln/>
+        </p:spPr>
+        <p:txBody>
+          <a:bodyPr wrap="square" lIns="0" tIns="0" rIns="0" bIns="0" rtlCol="0" anchor="ctr"/>
+          <a:lstStyle/>
+          <a:p>
+            <a:pPr algn="l" indent="0" marL="0">
+              <a:lnSpc>
+                <a:spcPct val="115000"/>
+              </a:lnSpc>
+              <a:buNone/>
+            </a:pPr>
+            <a:r>
+              <a:rPr lang="en-US" sz="1300" b="0" dirty="0">
+                <a:solidFill>
+                  <a:srgbClr val="8AA0B2"/>
+                </a:solidFill>
+                <a:latin typeface="Cambria" pitchFamily="34" charset="0"/>
+                <a:ea typeface="Cambria" pitchFamily="34" charset="-122"/>
+                <a:cs typeface="Cambria" pitchFamily="34" charset="-120"/>
+              </a:rPr>
+              <a:t>Tu laboratorio personal: energía del día, riesgo proyectado y calma guiada — todo desde tus propios datos.</a:t>
+            </a:r>
+            <a:endParaRPr lang="en-US" sz="2200" dirty="0"/>
+          </a:p>
+        </p:txBody>
+      </p:sp>
+      <p:sp>
+        <p:nvSpPr>
+          <p:cNvPr id="6" name="Shape 4"/>
+          <p:cNvSpPr/>
+          <p:nvPr/>
+        </p:nvSpPr>
+        <p:spPr>
+          <a:xfrm>
+            <a:off x="640080" y="4023360"/>
+            <a:ext cx="3474720" cy="1737360"/>
+          </a:xfrm>
+          <a:prstGeom prst="roundRect">
+            <a:avLst>
+              <a:gd name="adj" fmla="val 6316"/>
             </a:avLst>
           </a:prstGeom>
           <a:solidFill>
@@ -7829,56 +9290,84 @@
             <a:prstDash val="solid"/>
           </a:ln>
         </p:spPr>
-      </p:sp>
-      <p:sp>
-        <p:nvSpPr>
-          <p:cNvPr id="5" name="Text 3"/>
-          <p:cNvSpPr/>
-          <p:nvPr/>
-        </p:nvSpPr>
-        <p:spPr>
-          <a:xfrm>
-            <a:off x="914400" y="2057400"/>
-            <a:ext cx="2926080" cy="868680"/>
-          </a:xfrm>
-          <a:prstGeom prst="rect">
-            <a:avLst/>
-          </a:prstGeom>
-          <a:noFill/>
-          <a:ln/>
-        </p:spPr>
-        <p:txBody>
-          <a:bodyPr wrap="square" lIns="0" tIns="0" rIns="0" bIns="0" rtlCol="0" anchor="ctr"/>
-          <a:lstStyle/>
-          <a:p>
-            <a:pPr algn="l" indent="0" marL="0">
-              <a:buNone/>
-            </a:pPr>
-            <a:r>
-              <a:rPr lang="en-US" sz="4200" b="1" dirty="0">
-                <a:solidFill>
-                  <a:srgbClr val="4FD8C4"/>
+        <p:txBody>
+          <a:bodyPr/>
+          <a:p/>
+        </p:txBody>
+      </p:sp>
+      <p:sp>
+        <p:nvSpPr>
+          <p:cNvPr id="7" name="Shape 5"/>
+          <p:cNvSpPr/>
+          <p:nvPr/>
+        </p:nvSpPr>
+        <p:spPr>
+          <a:xfrm>
+            <a:off x="914400" y="4297680"/>
+            <a:ext cx="457200" cy="457200"/>
+          </a:xfrm>
+          <a:prstGeom prst="ellipse">
+            <a:avLst/>
+          </a:prstGeom>
+          <a:solidFill>
+            <a:srgbClr val="4FD8C4"/>
+          </a:solidFill>
+          <a:ln/>
+        </p:spPr>
+        <p:txBody>
+          <a:bodyPr/>
+          <a:p/>
+        </p:txBody>
+      </p:sp>
+      <p:sp>
+        <p:nvSpPr>
+          <p:cNvPr id="8" name="Text 6"/>
+          <p:cNvSpPr/>
+          <p:nvPr/>
+        </p:nvSpPr>
+        <p:spPr>
+          <a:xfrm>
+            <a:off x="1508760" y="4251960"/>
+            <a:ext cx="2468880" cy="548640"/>
+          </a:xfrm>
+          <a:prstGeom prst="rect">
+            <a:avLst/>
+          </a:prstGeom>
+          <a:noFill/>
+          <a:ln/>
+        </p:spPr>
+        <p:txBody>
+          <a:bodyPr wrap="square" lIns="0" tIns="0" rIns="0" bIns="0" rtlCol="0" anchor="ctr"/>
+          <a:lstStyle/>
+          <a:p>
+            <a:pPr indent="0" marL="0">
+              <a:buNone/>
+            </a:pPr>
+            <a:r>
+              <a:rPr lang="en-US" sz="1600" b="1" dirty="0">
+                <a:solidFill>
+                  <a:srgbClr val="EAF2F5"/>
                 </a:solidFill>
                 <a:latin typeface="Cambria" pitchFamily="34" charset="0"/>
                 <a:ea typeface="Cambria" pitchFamily="34" charset="-122"/>
                 <a:cs typeface="Cambria" pitchFamily="34" charset="-120"/>
               </a:rPr>
-              <a:t>0.99</a:t>
-            </a:r>
-            <a:endParaRPr lang="en-US" sz="4200" dirty="0"/>
-          </a:p>
-        </p:txBody>
-      </p:sp>
-      <p:sp>
-        <p:nvSpPr>
-          <p:cNvPr id="6" name="Text 4"/>
-          <p:cNvSpPr/>
-          <p:nvPr/>
-        </p:nvSpPr>
-        <p:spPr>
-          <a:xfrm>
-            <a:off x="914400" y="2971800"/>
-            <a:ext cx="2926080" cy="685800"/>
+              <a:t>Mapa de energía del día</a:t>
+            </a:r>
+            <a:endParaRPr lang="en-US" sz="1600" dirty="0"/>
+          </a:p>
+        </p:txBody>
+      </p:sp>
+      <p:sp>
+        <p:nvSpPr>
+          <p:cNvPr id="9" name="Text 7"/>
+          <p:cNvSpPr/>
+          <p:nvPr/>
+        </p:nvSpPr>
+        <p:spPr>
+          <a:xfrm>
+            <a:off x="914400" y="4937760"/>
+            <a:ext cx="2926080" cy="731520"/>
           </a:xfrm>
           <a:prstGeom prst="rect">
             <a:avLst/>
@@ -7897,7 +9386,7 @@
               <a:buNone/>
             </a:pPr>
             <a:r>
-              <a:rPr lang="en-US" sz="1350" dirty="0">
+              <a:rPr lang="en-US" sz="1300" dirty="0" b="0">
                 <a:solidFill>
                   <a:srgbClr val="8AA0B2"/>
                 </a:solidFill>
@@ -7905,46 +9394,26 @@
                 <a:ea typeface="Calibri" pitchFamily="34" charset="-122"/>
                 <a:cs typeface="Calibri" pitchFamily="34" charset="-120"/>
               </a:rPr>
-              <a:t>AUC de discriminación</a:t>
-            </a:r>
-            <a:endParaRPr lang="en-US" sz="1350" dirty="0"/>
-          </a:p>
-          <a:p>
-            <a:pPr algn="l" indent="0" marL="0">
-              <a:lnSpc>
-                <a:spcPct val="110000"/>
-              </a:lnSpc>
-              <a:buNone/>
-            </a:pPr>
-            <a:r>
-              <a:rPr lang="en-US" sz="1350" dirty="0">
-                <a:solidFill>
-                  <a:srgbClr val="8AA0B2"/>
-                </a:solidFill>
-                <a:latin typeface="Calibri" pitchFamily="34" charset="0"/>
-                <a:ea typeface="Calibri" pitchFamily="34" charset="-122"/>
-                <a:cs typeface="Calibri" pitchFamily="34" charset="-120"/>
-              </a:rPr>
-              <a:t>sobre datos reales (100k)</a:t>
-            </a:r>
-            <a:endParaRPr lang="en-US" sz="1350" dirty="0"/>
-          </a:p>
-        </p:txBody>
-      </p:sp>
-      <p:sp>
-        <p:nvSpPr>
-          <p:cNvPr id="7" name="Shape 5"/>
-          <p:cNvSpPr/>
-          <p:nvPr/>
-        </p:nvSpPr>
-        <p:spPr>
-          <a:xfrm>
-            <a:off x="4480560" y="1828800"/>
-            <a:ext cx="3474720" cy="1920240"/>
+              <a:t>Curva 8:00–22:00 que infiere picos y valles para saber cuándo entrenar o reunirte.</a:t>
+            </a:r>
+            <a:endParaRPr lang="en-US" sz="1300" dirty="0"/>
+          </a:p>
+        </p:txBody>
+      </p:sp>
+      <p:sp>
+        <p:nvSpPr>
+          <p:cNvPr id="10" name="Shape 8"/>
+          <p:cNvSpPr/>
+          <p:nvPr/>
+        </p:nvSpPr>
+        <p:spPr>
+          <a:xfrm>
+            <a:off x="4480560" y="4023360"/>
+            <a:ext cx="3474720" cy="1737360"/>
           </a:xfrm>
           <a:prstGeom prst="roundRect">
             <a:avLst>
-              <a:gd name="adj" fmla="val 5714"/>
+              <a:gd name="adj" fmla="val 6316"/>
             </a:avLst>
           </a:prstGeom>
           <a:solidFill>
@@ -7957,56 +9426,84 @@
             <a:prstDash val="solid"/>
           </a:ln>
         </p:spPr>
-      </p:sp>
-      <p:sp>
-        <p:nvSpPr>
-          <p:cNvPr id="8" name="Text 6"/>
-          <p:cNvSpPr/>
-          <p:nvPr/>
-        </p:nvSpPr>
-        <p:spPr>
-          <a:xfrm>
-            <a:off x="4754880" y="2057400"/>
-            <a:ext cx="2926080" cy="868680"/>
-          </a:xfrm>
-          <a:prstGeom prst="rect">
-            <a:avLst/>
-          </a:prstGeom>
-          <a:noFill/>
-          <a:ln/>
-        </p:spPr>
-        <p:txBody>
-          <a:bodyPr wrap="square" lIns="0" tIns="0" rIns="0" bIns="0" rtlCol="0" anchor="ctr"/>
-          <a:lstStyle/>
-          <a:p>
-            <a:pPr algn="l" indent="0" marL="0">
-              <a:buNone/>
-            </a:pPr>
-            <a:r>
-              <a:rPr lang="en-US" sz="4200" b="1" dirty="0">
-                <a:solidFill>
-                  <a:srgbClr val="9BA8F2"/>
+        <p:txBody>
+          <a:bodyPr/>
+          <a:p/>
+        </p:txBody>
+      </p:sp>
+      <p:sp>
+        <p:nvSpPr>
+          <p:cNvPr id="11" name="Shape 9"/>
+          <p:cNvSpPr/>
+          <p:nvPr/>
+        </p:nvSpPr>
+        <p:spPr>
+          <a:xfrm>
+            <a:off x="4754880" y="4297680"/>
+            <a:ext cx="457200" cy="457200"/>
+          </a:xfrm>
+          <a:prstGeom prst="ellipse">
+            <a:avLst/>
+          </a:prstGeom>
+          <a:solidFill>
+            <a:srgbClr val="9BA8F2"/>
+          </a:solidFill>
+          <a:ln/>
+        </p:spPr>
+        <p:txBody>
+          <a:bodyPr/>
+          <a:p/>
+        </p:txBody>
+      </p:sp>
+      <p:sp>
+        <p:nvSpPr>
+          <p:cNvPr id="12" name="Text 10"/>
+          <p:cNvSpPr/>
+          <p:nvPr/>
+        </p:nvSpPr>
+        <p:spPr>
+          <a:xfrm>
+            <a:off x="5349240" y="4251960"/>
+            <a:ext cx="2468880" cy="548640"/>
+          </a:xfrm>
+          <a:prstGeom prst="rect">
+            <a:avLst/>
+          </a:prstGeom>
+          <a:noFill/>
+          <a:ln/>
+        </p:spPr>
+        <p:txBody>
+          <a:bodyPr wrap="square" lIns="0" tIns="0" rIns="0" bIns="0" rtlCol="0" anchor="ctr"/>
+          <a:lstStyle/>
+          <a:p>
+            <a:pPr indent="0" marL="0">
+              <a:buNone/>
+            </a:pPr>
+            <a:r>
+              <a:rPr lang="en-US" sz="1600" b="1" dirty="0">
+                <a:solidFill>
+                  <a:srgbClr val="EAF2F5"/>
                 </a:solidFill>
                 <a:latin typeface="Cambria" pitchFamily="34" charset="0"/>
                 <a:ea typeface="Cambria" pitchFamily="34" charset="-122"/>
                 <a:cs typeface="Cambria" pitchFamily="34" charset="-120"/>
               </a:rPr>
-              <a:t>5-fold</a:t>
-            </a:r>
-            <a:endParaRPr lang="en-US" sz="4200" dirty="0"/>
-          </a:p>
-        </p:txBody>
-      </p:sp>
-      <p:sp>
-        <p:nvSpPr>
-          <p:cNvPr id="9" name="Text 7"/>
-          <p:cNvSpPr/>
-          <p:nvPr/>
-        </p:nvSpPr>
-        <p:spPr>
-          <a:xfrm>
-            <a:off x="4754880" y="2971800"/>
-            <a:ext cx="2926080" cy="685800"/>
+              <a:t>Proyección de riesgo 3 días</a:t>
+            </a:r>
+            <a:endParaRPr lang="en-US" sz="1600" dirty="0"/>
+          </a:p>
+        </p:txBody>
+      </p:sp>
+      <p:sp>
+        <p:nvSpPr>
+          <p:cNvPr id="13" name="Text 11"/>
+          <p:cNvSpPr/>
+          <p:nvPr/>
+        </p:nvSpPr>
+        <p:spPr>
+          <a:xfrm>
+            <a:off x="4754880" y="4937760"/>
+            <a:ext cx="2926080" cy="731520"/>
           </a:xfrm>
           <a:prstGeom prst="rect">
             <a:avLst/>
@@ -8025,7 +9522,7 @@
               <a:buNone/>
             </a:pPr>
             <a:r>
-              <a:rPr lang="en-US" sz="1350" dirty="0">
+              <a:rPr lang="en-US" sz="1300" dirty="0" b="0">
                 <a:solidFill>
                   <a:srgbClr val="8AA0B2"/>
                 </a:solidFill>
@@ -8033,46 +9530,26 @@
                 <a:ea typeface="Calibri" pitchFamily="34" charset="-122"/>
                 <a:cs typeface="Calibri" pitchFamily="34" charset="-120"/>
               </a:rPr>
-              <a:t>cross-validation</a:t>
-            </a:r>
-            <a:endParaRPr lang="en-US" sz="1350" dirty="0"/>
-          </a:p>
-          <a:p>
-            <a:pPr algn="l" indent="0" marL="0">
-              <a:lnSpc>
-                <a:spcPct val="110000"/>
-              </a:lnSpc>
-              <a:buNone/>
-            </a:pPr>
-            <a:r>
-              <a:rPr lang="en-US" sz="1350" dirty="0">
-                <a:solidFill>
-                  <a:srgbClr val="8AA0B2"/>
-                </a:solidFill>
-                <a:latin typeface="Calibri" pitchFamily="34" charset="0"/>
-                <a:ea typeface="Calibri" pitchFamily="34" charset="-122"/>
-                <a:cs typeface="Calibri" pitchFamily="34" charset="-120"/>
-              </a:rPr>
-              <a:t>estable, no suerte de un split</a:t>
-            </a:r>
-            <a:endParaRPr lang="en-US" sz="1350" dirty="0"/>
-          </a:p>
-        </p:txBody>
-      </p:sp>
-      <p:sp>
-        <p:nvSpPr>
-          <p:cNvPr id="10" name="Shape 8"/>
-          <p:cNvSpPr/>
-          <p:nvPr/>
-        </p:nvSpPr>
-        <p:spPr>
-          <a:xfrm>
-            <a:off x="8321040" y="1828800"/>
-            <a:ext cx="3474720" cy="1920240"/>
+              <a:t>Regresión sobre 7 días: 'si sigues así, en 3 días tu riesgo llegaría a X'. Avísate para actuar hoy.</a:t>
+            </a:r>
+            <a:endParaRPr lang="en-US" sz="1300" dirty="0"/>
+          </a:p>
+        </p:txBody>
+      </p:sp>
+      <p:sp>
+        <p:nvSpPr>
+          <p:cNvPr id="14" name="Shape 12"/>
+          <p:cNvSpPr/>
+          <p:nvPr/>
+        </p:nvSpPr>
+        <p:spPr>
+          <a:xfrm>
+            <a:off x="8321040" y="4023360"/>
+            <a:ext cx="3474720" cy="1737360"/>
           </a:xfrm>
           <a:prstGeom prst="roundRect">
             <a:avLst>
-              <a:gd name="adj" fmla="val 5714"/>
+              <a:gd name="adj" fmla="val 6316"/>
             </a:avLst>
           </a:prstGeom>
           <a:solidFill>
@@ -8085,56 +9562,84 @@
             <a:prstDash val="solid"/>
           </a:ln>
         </p:spPr>
-      </p:sp>
-      <p:sp>
-        <p:nvSpPr>
-          <p:cNvPr id="11" name="Text 9"/>
-          <p:cNvSpPr/>
-          <p:nvPr/>
-        </p:nvSpPr>
-        <p:spPr>
-          <a:xfrm>
-            <a:off x="8595360" y="2057400"/>
-            <a:ext cx="2926080" cy="868680"/>
-          </a:xfrm>
-          <a:prstGeom prst="rect">
-            <a:avLst/>
-          </a:prstGeom>
-          <a:noFill/>
-          <a:ln/>
-        </p:spPr>
-        <p:txBody>
-          <a:bodyPr wrap="square" lIns="0" tIns="0" rIns="0" bIns="0" rtlCol="0" anchor="ctr"/>
-          <a:lstStyle/>
-          <a:p>
-            <a:pPr algn="l" indent="0" marL="0">
-              <a:buNone/>
-            </a:pPr>
-            <a:r>
-              <a:rPr lang="en-US" sz="4200" b="1" dirty="0">
-                <a:solidFill>
-                  <a:srgbClr val="F2B84B"/>
+        <p:txBody>
+          <a:bodyPr/>
+          <a:p/>
+        </p:txBody>
+      </p:sp>
+      <p:sp>
+        <p:nvSpPr>
+          <p:cNvPr id="15" name="Shape 13"/>
+          <p:cNvSpPr/>
+          <p:nvPr/>
+        </p:nvSpPr>
+        <p:spPr>
+          <a:xfrm>
+            <a:off x="8595360" y="4297680"/>
+            <a:ext cx="457200" cy="457200"/>
+          </a:xfrm>
+          <a:prstGeom prst="ellipse">
+            <a:avLst/>
+          </a:prstGeom>
+          <a:solidFill>
+            <a:srgbClr val="F0687A"/>
+          </a:solidFill>
+          <a:ln/>
+        </p:spPr>
+        <p:txBody>
+          <a:bodyPr/>
+          <a:p/>
+        </p:txBody>
+      </p:sp>
+      <p:sp>
+        <p:nvSpPr>
+          <p:cNvPr id="16" name="Text 14"/>
+          <p:cNvSpPr/>
+          <p:nvPr/>
+        </p:nvSpPr>
+        <p:spPr>
+          <a:xfrm>
+            <a:off x="9189720" y="4251960"/>
+            <a:ext cx="2468880" cy="548640"/>
+          </a:xfrm>
+          <a:prstGeom prst="rect">
+            <a:avLst/>
+          </a:prstGeom>
+          <a:noFill/>
+          <a:ln/>
+        </p:spPr>
+        <p:txBody>
+          <a:bodyPr wrap="square" lIns="0" tIns="0" rIns="0" bIns="0" rtlCol="0" anchor="ctr"/>
+          <a:lstStyle/>
+          <a:p>
+            <a:pPr indent="0" marL="0">
+              <a:buNone/>
+            </a:pPr>
+            <a:r>
+              <a:rPr lang="en-US" sz="1600" b="1" dirty="0">
+                <a:solidFill>
+                  <a:srgbClr val="EAF2F5"/>
                 </a:solidFill>
                 <a:latin typeface="Cambria" pitchFamily="34" charset="0"/>
                 <a:ea typeface="Cambria" pitchFamily="34" charset="-122"/>
                 <a:cs typeface="Cambria" pitchFamily="34" charset="-120"/>
               </a:rPr>
-              <a:t>Honestos</a:t>
-            </a:r>
-            <a:endParaRPr lang="en-US" sz="4200" dirty="0"/>
-          </a:p>
-        </p:txBody>
-      </p:sp>
-      <p:sp>
-        <p:nvSpPr>
-          <p:cNvPr id="12" name="Text 10"/>
-          <p:cNvSpPr/>
-          <p:nvPr/>
-        </p:nvSpPr>
-        <p:spPr>
-          <a:xfrm>
-            <a:off x="8595360" y="2971800"/>
-            <a:ext cx="2926080" cy="685800"/>
+              <a:t>Respiración guiada 2 min</a:t>
+            </a:r>
+            <a:endParaRPr lang="en-US" sz="1600" dirty="0"/>
+          </a:p>
+        </p:txBody>
+      </p:sp>
+      <p:sp>
+        <p:nvSpPr>
+          <p:cNvPr id="17" name="Text 15"/>
+          <p:cNvSpPr/>
+          <p:nvPr/>
+        </p:nvSpPr>
+        <p:spPr>
+          <a:xfrm>
+            <a:off x="8595360" y="4937760"/>
+            <a:ext cx="2926080" cy="731520"/>
           </a:xfrm>
           <a:prstGeom prst="rect">
             <a:avLst/>
@@ -8153,7 +9658,7 @@
               <a:buNone/>
             </a:pPr>
             <a:r>
-              <a:rPr lang="en-US" sz="1350" dirty="0">
+              <a:rPr lang="en-US" sz="1300" dirty="0" b="0">
                 <a:solidFill>
                   <a:srgbClr val="8AA0B2"/>
                 </a:solidFill>
@@ -8161,145 +9666,15 @@
                 <a:ea typeface="Calibri" pitchFamily="34" charset="-122"/>
                 <a:cs typeface="Calibri" pitchFamily="34" charset="-120"/>
               </a:rPr>
-              <a:t>mostramos la matriz de</a:t>
-            </a:r>
-            <a:endParaRPr lang="en-US" sz="1350" dirty="0"/>
-          </a:p>
-          <a:p>
-            <a:pPr algn="l" indent="0" marL="0">
-              <a:lnSpc>
-                <a:spcPct val="110000"/>
-              </a:lnSpc>
-              <a:buNone/>
-            </a:pPr>
-            <a:r>
-              <a:rPr lang="en-US" sz="1350" dirty="0">
-                <a:solidFill>
-                  <a:srgbClr val="8AA0B2"/>
-                </a:solidFill>
-                <a:latin typeface="Calibri" pitchFamily="34" charset="0"/>
-                <a:ea typeface="Calibri" pitchFamily="34" charset="-122"/>
-                <a:cs typeface="Calibri" pitchFamily="34" charset="-120"/>
-              </a:rPr>
-              <a:t>confusión, falsos positivos incluidos</a:t>
-            </a:r>
-            <a:endParaRPr lang="en-US" sz="1350" dirty="0"/>
-          </a:p>
-        </p:txBody>
-      </p:sp>
-      <p:pic>
-        <p:nvPicPr>
-          <p:cNvPr id="13" name="Image 0" descr="C:\Users\ecard\OneDrive\Escritorio\BIOPULSE PROYECTO CIENCIA DE DATOS\.worktrees\pitch\files\feature_importance_rf.png">    </p:cNvPr>
-          <p:cNvPicPr>
-            <a:picLocks noChangeAspect="1"/>
-          </p:cNvPicPr>
-          <p:nvPr/>
-        </p:nvPicPr>
-        <p:blipFill>
-          <a:blip r:embed="rId1"/>
-          <a:stretch>
-            <a:fillRect/>
-          </a:stretch>
-        </p:blipFill>
-        <p:spPr>
-          <a:xfrm>
-            <a:off x="640080" y="4023360"/>
-            <a:ext cx="3453003" cy="2423160"/>
-          </a:xfrm>
-          <a:prstGeom prst="rect">
-            <a:avLst/>
-          </a:prstGeom>
-        </p:spPr>
-      </p:pic>
-      <p:sp>
-        <p:nvSpPr>
-          <p:cNvPr id="14" name="Shape 11"/>
-          <p:cNvSpPr/>
-          <p:nvPr/>
-        </p:nvSpPr>
-        <p:spPr>
-          <a:xfrm>
-            <a:off x="4434840" y="4023360"/>
-            <a:ext cx="7086600" cy="2423160"/>
-          </a:xfrm>
-          <a:prstGeom prst="roundRect">
-            <a:avLst>
-              <a:gd name="adj" fmla="val 4528"/>
-            </a:avLst>
-          </a:prstGeom>
-          <a:solidFill>
-            <a:srgbClr val="0D1B2A"/>
-          </a:solidFill>
-          <a:ln w="12700">
-            <a:solidFill>
-              <a:srgbClr val="1D3348"/>
-            </a:solidFill>
-            <a:prstDash val="solid"/>
-          </a:ln>
-        </p:spPr>
-      </p:sp>
-      <p:sp>
-        <p:nvSpPr>
-          <p:cNvPr id="15" name="Text 12"/>
-          <p:cNvSpPr/>
-          <p:nvPr/>
-        </p:nvSpPr>
-        <p:spPr>
-          <a:xfrm>
-            <a:off x="4663440" y="4160520"/>
-            <a:ext cx="6629400" cy="2148840"/>
-          </a:xfrm>
-          <a:prstGeom prst="rect">
-            <a:avLst/>
-          </a:prstGeom>
-          <a:noFill/>
-          <a:ln/>
-        </p:spPr>
-        <p:txBody>
-          <a:bodyPr wrap="square" lIns="0" tIns="0" rIns="0" bIns="0" rtlCol="0" anchor="ctr"/>
-          <a:lstStyle/>
-          <a:p>
-            <a:pPr algn="l" indent="0" marL="0">
-              <a:buNone/>
-            </a:pPr>
-            <a:r>
-              <a:rPr lang="en-US" sz="1150" b="1" spc="100" kern="0" dirty="0">
-                <a:solidFill>
-                  <a:srgbClr val="4FD8C4"/>
-                </a:solidFill>
-                <a:latin typeface="Calibri" pitchFamily="34" charset="0"/>
-                <a:ea typeface="Calibri" pitchFamily="34" charset="-122"/>
-                <a:cs typeface="Calibri" pitchFamily="34" charset="-120"/>
-              </a:rPr>
-              <a:t>POR QUÉ CONFIAR  ·  </a:t>
-            </a:r>
-            <a:endParaRPr lang="en-US" sz="1150" dirty="0"/>
-          </a:p>
-          <a:p>
-            <a:pPr algn="l" indent="0" marL="0">
-              <a:lnSpc>
-                <a:spcPct val="125000"/>
-              </a:lnSpc>
-              <a:buNone/>
-            </a:pPr>
-            <a:r>
-              <a:rPr lang="en-US" sz="1400" dirty="0">
-                <a:solidFill>
-                  <a:srgbClr val="EAF2F5"/>
-                </a:solidFill>
-                <a:latin typeface="Calibri" pitchFamily="34" charset="0"/>
-                <a:ea typeface="Calibri" pitchFamily="34" charset="-122"/>
-                <a:cs typeface="Calibri" pitchFamily="34" charset="-120"/>
-              </a:rPr>
-              <a:t>El modelo aprendió solo que la temperatura de piel y la recuperación son las señales más predictivas — justo lo que dice la literatura clínica sobre infecciones y fatiga tempranas. La máquina coincide con los médicos.</a:t>
-            </a:r>
-            <a:endParaRPr lang="en-US" sz="1150" dirty="0"/>
-          </a:p>
-        </p:txBody>
-      </p:sp>
-      <p:sp>
-        <p:nvSpPr>
-          <p:cNvPr id="16" name="Text 13"/>
+              <a:t>Anillo que respira contigo para calmar el sistema nervioso al instante. Cero datos nuevos.</a:t>
+            </a:r>
+            <a:endParaRPr lang="en-US" sz="1300" dirty="0"/>
+          </a:p>
+        </p:txBody>
+      </p:sp>
+      <p:sp>
+        <p:nvSpPr>
+          <p:cNvPr id="18" name="Text 16"/>
           <p:cNvSpPr/>
           <p:nvPr/>
         </p:nvSpPr>
@@ -8338,7 +9713,7 @@
       </p:sp>
       <p:sp>
         <p:nvSpPr>
-          <p:cNvPr id="17" name="Text 14"/>
+          <p:cNvPr id="19" name="Text 17"/>
           <p:cNvSpPr/>
           <p:nvPr/>
         </p:nvSpPr>
@@ -8361,7 +9736,7 @@
               <a:buNone/>
             </a:pPr>
             <a:r>
-              <a:rPr lang="en-US" sz="900" dirty="0">
+              <a:rPr lang="en-US" sz="900" dirty="0" b="0">
                 <a:solidFill>
                   <a:srgbClr val="8AA0B2"/>
                 </a:solidFill>
@@ -8384,29 +9759,15 @@
 </file>
 
 <file path=ppt/slides/slide9.xml><?xml version="1.0" encoding="utf-8"?>
-<p:sld xmlns:a="http://schemas.openxmlformats.org/drawingml/2006/main" xmlns:r="http://schemas.openxmlformats.org/officeDocument/2006/relationships" xmlns:p="http://schemas.openxmlformats.org/presentationml/2006/main">
-  <p:cSld name="Slide 9">
-    <p:bg>
-      <p:bgPr>
-        <a:solidFill>
-          <a:srgbClr val="0A1420"/>
-        </a:solidFill>
-      </p:bgPr>
-    </p:bg>
+<p:sld xmlns:a="http://schemas.openxmlformats.org/drawingml/2006/main" xmlns:p="http://schemas.openxmlformats.org/presentationml/2006/main" xmlns:r="http://schemas.openxmlformats.org/officeDocument/2006/relationships">
+  <p:cSld>
     <p:spTree>
       <p:nvGrpSpPr>
         <p:cNvPr id="1" name=""/>
         <p:cNvGrpSpPr/>
         <p:nvPr/>
       </p:nvGrpSpPr>
-      <p:grpSpPr>
-        <a:xfrm>
-          <a:off x="0" y="0"/>
-          <a:ext cx="0" cy="0"/>
-          <a:chOff x="0" y="0"/>
-          <a:chExt cx="0" cy="0"/>
-        </a:xfrm>
-      </p:grpSpPr>
+      <p:grpSpPr/>
       <p:sp>
         <p:nvSpPr>
           <p:cNvPr id="2" name="Text 0"/>
@@ -8434,13 +9795,13 @@
             <a:r>
               <a:rPr lang="en-US" sz="1200" b="1" spc="200" kern="0" dirty="0">
                 <a:solidFill>
-                  <a:srgbClr val="F2B84B"/>
-                </a:solidFill>
-                <a:latin typeface="Calibri" pitchFamily="34" charset="0"/>
-                <a:ea typeface="Calibri" pitchFamily="34" charset="-122"/>
-                <a:cs typeface="Calibri" pitchFamily="34" charset="-120"/>
-              </a:rPr>
-              <a:t>MERCADO</a:t>
+                  <a:srgbClr val="4FD8C4"/>
+                </a:solidFill>
+                <a:latin typeface="Calibri" pitchFamily="34" charset="0"/>
+                <a:ea typeface="Calibri" pitchFamily="34" charset="-122"/>
+                <a:cs typeface="Calibri" pitchFamily="34" charset="-120"/>
+              </a:rPr>
+              <a:t>BIENESTAR + COACH</a:t>
             </a:r>
             <a:endParaRPr lang="en-US" sz="1200" dirty="0"/>
           </a:p>
@@ -8482,7 +9843,7 @@
                 <a:ea typeface="Cambria" pitchFamily="34" charset="-122"/>
                 <a:cs typeface="Cambria" pitchFamily="34" charset="-120"/>
               </a:rPr>
-              <a:t>Una ventana abierta, justo ahora</a:t>
+              <a:t>No solo el riesgo: tu recuperación y un plan</a:t>
             </a:r>
             <a:endParaRPr lang="en-US" sz="3400" dirty="0"/>
           </a:p>
@@ -8496,16 +9857,16 @@
         </p:nvSpPr>
         <p:spPr>
           <a:xfrm>
-            <a:off x="640080" y="1828800"/>
-            <a:ext cx="3474720" cy="2834640"/>
+            <a:off x="640080" y="1920240"/>
+            <a:ext cx="10881360" cy="1828800"/>
           </a:xfrm>
           <a:prstGeom prst="roundRect">
             <a:avLst>
-              <a:gd name="adj" fmla="val 3871"/>
+              <a:gd name="adj" fmla="val 6000"/>
             </a:avLst>
           </a:prstGeom>
           <a:solidFill>
-            <a:srgbClr val="101F30"/>
+            <a:srgbClr val="0D1B2A"/>
           </a:solidFill>
           <a:ln w="12700">
             <a:solidFill>
@@ -8514,122 +9875,67 @@
             <a:prstDash val="solid"/>
           </a:ln>
         </p:spPr>
-      </p:sp>
-      <p:sp>
-        <p:nvSpPr>
-          <p:cNvPr id="5" name="Shape 3"/>
-          <p:cNvSpPr/>
-          <p:nvPr/>
-        </p:nvSpPr>
-        <p:spPr>
-          <a:xfrm>
-            <a:off x="914400" y="2148840"/>
-            <a:ext cx="548640" cy="548640"/>
-          </a:xfrm>
-          <a:prstGeom prst="ellipse">
-            <a:avLst/>
-          </a:prstGeom>
-          <a:solidFill>
-            <a:srgbClr val="4FD8C4"/>
-          </a:solidFill>
-          <a:ln/>
-        </p:spPr>
-      </p:sp>
-      <p:sp>
-        <p:nvSpPr>
-          <p:cNvPr id="6" name="Text 4"/>
-          <p:cNvSpPr/>
-          <p:nvPr/>
-        </p:nvSpPr>
-        <p:spPr>
-          <a:xfrm>
-            <a:off x="1600200" y="2148840"/>
-            <a:ext cx="2286000" cy="548640"/>
-          </a:xfrm>
-          <a:prstGeom prst="rect">
-            <a:avLst/>
-          </a:prstGeom>
-          <a:noFill/>
-          <a:ln/>
-        </p:spPr>
-        <p:txBody>
-          <a:bodyPr wrap="square" lIns="0" tIns="0" rIns="0" bIns="0" rtlCol="0" anchor="ctr"/>
-          <a:lstStyle/>
-          <a:p>
-            <a:pPr indent="0" marL="0">
-              <a:buNone/>
-            </a:pPr>
-            <a:r>
-              <a:rPr lang="en-US" sz="1500" b="1" dirty="0">
-                <a:solidFill>
-                  <a:srgbClr val="EAF2F5"/>
+        <p:txBody>
+          <a:bodyPr/>
+          <a:p/>
+        </p:txBody>
+      </p:sp>
+      <p:sp>
+        <p:nvSpPr>
+          <p:cNvPr id="5" name="Text 3"/>
+          <p:cNvSpPr/>
+          <p:nvPr/>
+        </p:nvSpPr>
+        <p:spPr>
+          <a:xfrm>
+            <a:off x="914400" y="2103120"/>
+            <a:ext cx="10332720" cy="1463040"/>
+          </a:xfrm>
+          <a:prstGeom prst="rect">
+            <a:avLst/>
+          </a:prstGeom>
+          <a:noFill/>
+          <a:ln/>
+        </p:spPr>
+        <p:txBody>
+          <a:bodyPr wrap="square" lIns="0" tIns="0" rIns="0" bIns="0" rtlCol="0" anchor="ctr"/>
+          <a:lstStyle/>
+          <a:p>
+            <a:pPr algn="l" indent="0" marL="0">
+              <a:lnSpc>
+                <a:spcPct val="115000"/>
+              </a:lnSpc>
+              <a:buNone/>
+            </a:pPr>
+            <a:r>
+              <a:rPr lang="en-US" sz="1300" b="0" dirty="0">
+                <a:solidFill>
+                  <a:srgbClr val="8AA0B2"/>
                 </a:solidFill>
                 <a:latin typeface="Cambria" pitchFamily="34" charset="0"/>
                 <a:ea typeface="Cambria" pitchFamily="34" charset="-122"/>
                 <a:cs typeface="Cambria" pitchFamily="34" charset="-120"/>
               </a:rPr>
-              <a:t>Wearables en auge</a:t>
-            </a:r>
-            <a:endParaRPr lang="en-US" sz="1500" dirty="0"/>
-          </a:p>
-        </p:txBody>
-      </p:sp>
-      <p:sp>
-        <p:nvSpPr>
-          <p:cNvPr id="7" name="Text 5"/>
-          <p:cNvSpPr/>
-          <p:nvPr/>
-        </p:nvSpPr>
-        <p:spPr>
-          <a:xfrm>
-            <a:off x="914400" y="2971800"/>
-            <a:ext cx="2926080" cy="1554480"/>
-          </a:xfrm>
-          <a:prstGeom prst="rect">
-            <a:avLst/>
-          </a:prstGeom>
-          <a:noFill/>
-          <a:ln/>
-        </p:spPr>
-        <p:txBody>
-          <a:bodyPr wrap="square" lIns="0" tIns="0" rIns="0" bIns="0" rtlCol="0" anchor="ctr"/>
-          <a:lstStyle/>
-          <a:p>
-            <a:pPr algn="l" indent="0" marL="0">
-              <a:lnSpc>
-                <a:spcPct val="125000"/>
-              </a:lnSpc>
-              <a:buNone/>
-            </a:pPr>
-            <a:r>
-              <a:rPr lang="en-US" sz="1350" dirty="0">
-                <a:solidFill>
-                  <a:srgbClr val="8AA0B2"/>
-                </a:solidFill>
-                <a:latin typeface="Calibri" pitchFamily="34" charset="0"/>
-                <a:ea typeface="Calibri" pitchFamily="34" charset="-122"/>
-                <a:cs typeface="Calibri" pitchFamily="34" charset="-120"/>
-              </a:rPr>
-              <a:t>Cada vez más relojes y pulseras inteligentes en muñecas; la demanda de “más que pasos” crece.</a:t>
-            </a:r>
-            <a:endParaRPr lang="en-US" sz="1350" dirty="0"/>
-          </a:p>
-        </p:txBody>
-      </p:sp>
-      <p:sp>
-        <p:nvSpPr>
-          <p:cNvPr id="8" name="Shape 6"/>
-          <p:cNvSpPr/>
-          <p:nvPr/>
-        </p:nvSpPr>
-        <p:spPr>
-          <a:xfrm>
-            <a:off x="4480560" y="1828800"/>
-            <a:ext cx="3474720" cy="2834640"/>
+              <a:t>BioScore y Sleep Score para bienestar; Coach con Plan de hoy accionable; diseño iOS 26 claro/oscuro.</a:t>
+            </a:r>
+            <a:endParaRPr lang="en-US" sz="2200" dirty="0"/>
+          </a:p>
+        </p:txBody>
+      </p:sp>
+      <p:sp>
+        <p:nvSpPr>
+          <p:cNvPr id="6" name="Shape 4"/>
+          <p:cNvSpPr/>
+          <p:nvPr/>
+        </p:nvSpPr>
+        <p:spPr>
+          <a:xfrm>
+            <a:off x="640080" y="4023360"/>
+            <a:ext cx="3474720" cy="1737360"/>
           </a:xfrm>
           <a:prstGeom prst="roundRect">
             <a:avLst>
-              <a:gd name="adj" fmla="val 3871"/>
+              <a:gd name="adj" fmla="val 6316"/>
             </a:avLst>
           </a:prstGeom>
           <a:solidFill>
@@ -8637,42 +9943,50 @@
           </a:solidFill>
           <a:ln w="12700">
             <a:solidFill>
-              <a:srgbClr val="F0687A"/>
+              <a:srgbClr val="1D3348"/>
             </a:solidFill>
             <a:prstDash val="solid"/>
           </a:ln>
         </p:spPr>
-      </p:sp>
-      <p:sp>
-        <p:nvSpPr>
-          <p:cNvPr id="9" name="Shape 7"/>
-          <p:cNvSpPr/>
-          <p:nvPr/>
-        </p:nvSpPr>
-        <p:spPr>
-          <a:xfrm>
-            <a:off x="4754880" y="2148840"/>
-            <a:ext cx="548640" cy="548640"/>
+        <p:txBody>
+          <a:bodyPr/>
+          <a:p/>
+        </p:txBody>
+      </p:sp>
+      <p:sp>
+        <p:nvSpPr>
+          <p:cNvPr id="7" name="Shape 5"/>
+          <p:cNvSpPr/>
+          <p:nvPr/>
+        </p:nvSpPr>
+        <p:spPr>
+          <a:xfrm>
+            <a:off x="914400" y="4297680"/>
+            <a:ext cx="457200" cy="457200"/>
           </a:xfrm>
           <a:prstGeom prst="ellipse">
             <a:avLst/>
           </a:prstGeom>
           <a:solidFill>
-            <a:srgbClr val="F0687A"/>
+            <a:srgbClr val="4FD8C4"/>
           </a:solidFill>
           <a:ln/>
         </p:spPr>
-      </p:sp>
-      <p:sp>
-        <p:nvSpPr>
-          <p:cNvPr id="10" name="Text 8"/>
-          <p:cNvSpPr/>
-          <p:nvPr/>
-        </p:nvSpPr>
-        <p:spPr>
-          <a:xfrm>
-            <a:off x="5440680" y="2148840"/>
-            <a:ext cx="2286000" cy="548640"/>
+        <p:txBody>
+          <a:bodyPr/>
+          <a:p/>
+        </p:txBody>
+      </p:sp>
+      <p:sp>
+        <p:nvSpPr>
+          <p:cNvPr id="8" name="Text 6"/>
+          <p:cNvSpPr/>
+          <p:nvPr/>
+        </p:nvSpPr>
+        <p:spPr>
+          <a:xfrm>
+            <a:off x="1508760" y="4251960"/>
+            <a:ext cx="2468880" cy="548640"/>
           </a:xfrm>
           <a:prstGeom prst="rect">
             <a:avLst/>
@@ -8688,7 +10002,7 @@
               <a:buNone/>
             </a:pPr>
             <a:r>
-              <a:rPr lang="en-US" sz="1500" b="1" dirty="0">
+              <a:rPr lang="en-US" sz="1600" b="1" dirty="0">
                 <a:solidFill>
                   <a:srgbClr val="EAF2F5"/>
                 </a:solidFill>
@@ -8696,22 +10010,22 @@
                 <a:ea typeface="Cambria" pitchFamily="34" charset="-122"/>
                 <a:cs typeface="Cambria" pitchFamily="34" charset="-120"/>
               </a:rPr>
-              <a:t>Población que envejece</a:t>
-            </a:r>
-            <a:endParaRPr lang="en-US" sz="1500" dirty="0"/>
-          </a:p>
-        </p:txBody>
-      </p:sp>
-      <p:sp>
-        <p:nvSpPr>
-          <p:cNvPr id="11" name="Text 9"/>
-          <p:cNvSpPr/>
-          <p:nvPr/>
-        </p:nvSpPr>
-        <p:spPr>
-          <a:xfrm>
-            <a:off x="4754880" y="2971800"/>
-            <a:ext cx="2926080" cy="1554480"/>
+              <a:t>BioScore + Sleep Score</a:t>
+            </a:r>
+            <a:endParaRPr lang="en-US" sz="1600" dirty="0"/>
+          </a:p>
+        </p:txBody>
+      </p:sp>
+      <p:sp>
+        <p:nvSpPr>
+          <p:cNvPr id="9" name="Text 7"/>
+          <p:cNvSpPr/>
+          <p:nvPr/>
+        </p:nvSpPr>
+        <p:spPr>
+          <a:xfrm>
+            <a:off x="914400" y="4937760"/>
+            <a:ext cx="2926080" cy="731520"/>
           </a:xfrm>
           <a:prstGeom prst="rect">
             <a:avLst/>
@@ -8725,12 +10039,12 @@
           <a:p>
             <a:pPr algn="l" indent="0" marL="0">
               <a:lnSpc>
-                <a:spcPct val="125000"/>
+                <a:spcPct val="110000"/>
               </a:lnSpc>
               <a:buNone/>
             </a:pPr>
             <a:r>
-              <a:rPr lang="en-US" sz="1350" dirty="0">
+              <a:rPr lang="en-US" sz="1300" dirty="0" b="0">
                 <a:solidFill>
                   <a:srgbClr val="8AA0B2"/>
                 </a:solidFill>
@@ -8738,26 +10052,26 @@
                 <a:ea typeface="Calibri" pitchFamily="34" charset="-122"/>
                 <a:cs typeface="Calibri" pitchFamily="34" charset="-120"/>
               </a:rPr>
-              <a:t>Más adultos mayores, más caídas e infecciones prevenibles que el sistema no detecta a tiempo.</a:t>
-            </a:r>
-            <a:endParaRPr lang="en-US" sz="1350" dirty="0"/>
-          </a:p>
-        </p:txBody>
-      </p:sp>
-      <p:sp>
-        <p:nvSpPr>
-          <p:cNvPr id="12" name="Shape 10"/>
-          <p:cNvSpPr/>
-          <p:nvPr/>
-        </p:nvSpPr>
-        <p:spPr>
-          <a:xfrm>
-            <a:off x="8321040" y="1828800"/>
-            <a:ext cx="3474720" cy="2834640"/>
+              <a:t>Índice de bienestar (mayor=mejor) y sueño predictivo desde HRV, RHR y recuperación reales.</a:t>
+            </a:r>
+            <a:endParaRPr lang="en-US" sz="1300" dirty="0"/>
+          </a:p>
+        </p:txBody>
+      </p:sp>
+      <p:sp>
+        <p:nvSpPr>
+          <p:cNvPr id="10" name="Shape 8"/>
+          <p:cNvSpPr/>
+          <p:nvPr/>
+        </p:nvSpPr>
+        <p:spPr>
+          <a:xfrm>
+            <a:off x="4480560" y="4023360"/>
+            <a:ext cx="3474720" cy="1737360"/>
           </a:xfrm>
           <a:prstGeom prst="roundRect">
             <a:avLst>
-              <a:gd name="adj" fmla="val 3871"/>
+              <a:gd name="adj" fmla="val 6316"/>
             </a:avLst>
           </a:prstGeom>
           <a:solidFill>
@@ -8765,22 +10079,26 @@
           </a:solidFill>
           <a:ln w="12700">
             <a:solidFill>
-              <a:srgbClr val="9BA8F2"/>
+              <a:srgbClr val="1D3348"/>
             </a:solidFill>
             <a:prstDash val="solid"/>
           </a:ln>
         </p:spPr>
-      </p:sp>
-      <p:sp>
-        <p:nvSpPr>
-          <p:cNvPr id="13" name="Shape 11"/>
-          <p:cNvSpPr/>
-          <p:nvPr/>
-        </p:nvSpPr>
-        <p:spPr>
-          <a:xfrm>
-            <a:off x="8595360" y="2148840"/>
-            <a:ext cx="548640" cy="548640"/>
+        <p:txBody>
+          <a:bodyPr/>
+          <a:p/>
+        </p:txBody>
+      </p:sp>
+      <p:sp>
+        <p:nvSpPr>
+          <p:cNvPr id="11" name="Shape 9"/>
+          <p:cNvSpPr/>
+          <p:nvPr/>
+        </p:nvSpPr>
+        <p:spPr>
+          <a:xfrm>
+            <a:off x="4754880" y="4297680"/>
+            <a:ext cx="457200" cy="457200"/>
           </a:xfrm>
           <a:prstGeom prst="ellipse">
             <a:avLst/>
@@ -8790,17 +10108,21 @@
           </a:solidFill>
           <a:ln/>
         </p:spPr>
-      </p:sp>
-      <p:sp>
-        <p:nvSpPr>
-          <p:cNvPr id="14" name="Text 12"/>
-          <p:cNvSpPr/>
-          <p:nvPr/>
-        </p:nvSpPr>
-        <p:spPr>
-          <a:xfrm>
-            <a:off x="9281160" y="2148840"/>
-            <a:ext cx="2286000" cy="548640"/>
+        <p:txBody>
+          <a:bodyPr/>
+          <a:p/>
+        </p:txBody>
+      </p:sp>
+      <p:sp>
+        <p:nvSpPr>
+          <p:cNvPr id="12" name="Text 10"/>
+          <p:cNvSpPr/>
+          <p:nvPr/>
+        </p:nvSpPr>
+        <p:spPr>
+          <a:xfrm>
+            <a:off x="5349240" y="4251960"/>
+            <a:ext cx="2468880" cy="548640"/>
           </a:xfrm>
           <a:prstGeom prst="rect">
             <a:avLst/>
@@ -8816,7 +10138,7 @@
               <a:buNone/>
             </a:pPr>
             <a:r>
-              <a:rPr lang="en-US" sz="1500" b="1" dirty="0">
+              <a:rPr lang="en-US" sz="1600" b="1" dirty="0">
                 <a:solidFill>
                   <a:srgbClr val="EAF2F5"/>
                 </a:solidFill>
@@ -8824,22 +10146,22 @@
                 <a:ea typeface="Cambria" pitchFamily="34" charset="-122"/>
                 <a:cs typeface="Cambria" pitchFamily="34" charset="-120"/>
               </a:rPr>
-              <a:t>El cuello de botella</a:t>
-            </a:r>
-            <a:endParaRPr lang="en-US" sz="1500" dirty="0"/>
-          </a:p>
-        </p:txBody>
-      </p:sp>
-      <p:sp>
-        <p:nvSpPr>
-          <p:cNvPr id="15" name="Text 13"/>
-          <p:cNvSpPr/>
-          <p:nvPr/>
-        </p:nvSpPr>
-        <p:spPr>
-          <a:xfrm>
-            <a:off x="8595360" y="2971800"/>
-            <a:ext cx="2926080" cy="1554480"/>
+              <a:t>Plan de hoy (IA)</a:t>
+            </a:r>
+            <a:endParaRPr lang="en-US" sz="1600" dirty="0"/>
+          </a:p>
+        </p:txBody>
+      </p:sp>
+      <p:sp>
+        <p:nvSpPr>
+          <p:cNvPr id="13" name="Text 11"/>
+          <p:cNvSpPr/>
+          <p:nvPr/>
+        </p:nvSpPr>
+        <p:spPr>
+          <a:xfrm>
+            <a:off x="4754880" y="4937760"/>
+            <a:ext cx="2926080" cy="731520"/>
           </a:xfrm>
           <a:prstGeom prst="rect">
             <a:avLst/>
@@ -8853,12 +10175,12 @@
           <a:p>
             <a:pPr algn="l" indent="0" marL="0">
               <a:lnSpc>
-                <a:spcPct val="125000"/>
+                <a:spcPct val="110000"/>
               </a:lnSpc>
               <a:buNone/>
             </a:pPr>
             <a:r>
-              <a:rPr lang="en-US" sz="1350" dirty="0">
+              <a:rPr lang="en-US" sz="1300" dirty="0" b="0">
                 <a:solidFill>
                   <a:srgbClr val="8AA0B2"/>
                 </a:solidFill>
@@ -8866,10 +10188,65 @@
                 <a:ea typeface="Calibri" pitchFamily="34" charset="-122"/>
                 <a:cs typeface="Calibri" pitchFamily="34" charset="-120"/>
               </a:rPr>
-              <a:t>La capa de IA predictiva de salud está vacía. El hardware existe; la inteligencia no.</a:t>
-            </a:r>
-            <a:endParaRPr lang="en-US" sz="1350" dirty="0"/>
-          </a:p>
+              <a:t>Si el riesgo sube, el Coach da 3 pasos accionables personalizados con tus métricas del día.</a:t>
+            </a:r>
+            <a:endParaRPr lang="en-US" sz="1300" dirty="0"/>
+          </a:p>
+        </p:txBody>
+      </p:sp>
+      <p:sp>
+        <p:nvSpPr>
+          <p:cNvPr id="14" name="Shape 12"/>
+          <p:cNvSpPr/>
+          <p:nvPr/>
+        </p:nvSpPr>
+        <p:spPr>
+          <a:xfrm>
+            <a:off x="8321040" y="4023360"/>
+            <a:ext cx="3474720" cy="1737360"/>
+          </a:xfrm>
+          <a:prstGeom prst="roundRect">
+            <a:avLst>
+              <a:gd name="adj" fmla="val 6316"/>
+            </a:avLst>
+          </a:prstGeom>
+          <a:solidFill>
+            <a:srgbClr val="101F30"/>
+          </a:solidFill>
+          <a:ln w="12700">
+            <a:solidFill>
+              <a:srgbClr val="1D3348"/>
+            </a:solidFill>
+            <a:prstDash val="solid"/>
+          </a:ln>
+        </p:spPr>
+        <p:txBody>
+          <a:bodyPr/>
+          <a:p/>
+        </p:txBody>
+      </p:sp>
+      <p:sp>
+        <p:nvSpPr>
+          <p:cNvPr id="15" name="Shape 13"/>
+          <p:cNvSpPr/>
+          <p:nvPr/>
+        </p:nvSpPr>
+        <p:spPr>
+          <a:xfrm>
+            <a:off x="8595360" y="4297680"/>
+            <a:ext cx="457200" cy="457200"/>
+          </a:xfrm>
+          <a:prstGeom prst="ellipse">
+            <a:avLst/>
+          </a:prstGeom>
+          <a:solidFill>
+            <a:srgbClr val="F0687A"/>
+          </a:solidFill>
+          <a:ln/>
+        </p:spPr>
+        <p:txBody>
+          <a:bodyPr/>
+          <a:p/>
         </p:txBody>
       </p:sp>
       <p:sp>
@@ -8880,8 +10257,47 @@
         </p:nvSpPr>
         <p:spPr>
           <a:xfrm>
-            <a:off x="640080" y="4937760"/>
-            <a:ext cx="11064240" cy="1005840"/>
+            <a:off x="9189720" y="4251960"/>
+            <a:ext cx="2468880" cy="548640"/>
+          </a:xfrm>
+          <a:prstGeom prst="rect">
+            <a:avLst/>
+          </a:prstGeom>
+          <a:noFill/>
+          <a:ln/>
+        </p:spPr>
+        <p:txBody>
+          <a:bodyPr wrap="square" lIns="0" tIns="0" rIns="0" bIns="0" rtlCol="0" anchor="ctr"/>
+          <a:lstStyle/>
+          <a:p>
+            <a:pPr indent="0" marL="0">
+              <a:buNone/>
+            </a:pPr>
+            <a:r>
+              <a:rPr lang="en-US" sz="1600" b="1" dirty="0">
+                <a:solidFill>
+                  <a:srgbClr val="EAF2F5"/>
+                </a:solidFill>
+                <a:latin typeface="Cambria" pitchFamily="34" charset="0"/>
+                <a:ea typeface="Cambria" pitchFamily="34" charset="-122"/>
+                <a:cs typeface="Cambria" pitchFamily="34" charset="-120"/>
+              </a:rPr>
+              <a:t>Diseño iOS 26 + claro/oscuro</a:t>
+            </a:r>
+            <a:endParaRPr lang="en-US" sz="1600" dirty="0"/>
+          </a:p>
+        </p:txBody>
+      </p:sp>
+      <p:sp>
+        <p:nvSpPr>
+          <p:cNvPr id="17" name="Text 15"/>
+          <p:cNvSpPr/>
+          <p:nvPr/>
+        </p:nvSpPr>
+        <p:spPr>
+          <a:xfrm>
+            <a:off x="8595360" y="4937760"/>
+            <a:ext cx="2926080" cy="731520"/>
           </a:xfrm>
           <a:prstGeom prst="rect">
             <a:avLst/>
@@ -8895,28 +10311,28 @@
           <a:p>
             <a:pPr algn="l" indent="0" marL="0">
               <a:lnSpc>
-                <a:spcPct val="120000"/>
+                <a:spcPct val="110000"/>
               </a:lnSpc>
               <a:buNone/>
             </a:pPr>
             <a:r>
-              <a:rPr lang="en-US" sz="1600" i="1" dirty="0">
-                <a:solidFill>
-                  <a:srgbClr val="EAF2F5"/>
-                </a:solidFill>
-                <a:latin typeface="Calibri" pitchFamily="34" charset="0"/>
-                <a:ea typeface="Calibri" pitchFamily="34" charset="-122"/>
-                <a:cs typeface="Calibri" pitchFamily="34" charset="-120"/>
-              </a:rPr>
-              <a:t>El hardware ya está en la muñeca de millones. Solo falta la capa que convierta esos datos en cuidado. Esa capa somos nosotros.</a:t>
-            </a:r>
-            <a:endParaRPr lang="en-US" sz="1600" dirty="0"/>
-          </a:p>
-        </p:txBody>
-      </p:sp>
-      <p:sp>
-        <p:nvSpPr>
-          <p:cNvPr id="17" name="Text 15"/>
+              <a:rPr lang="en-US" sz="1300" dirty="0" b="0">
+                <a:solidFill>
+                  <a:srgbClr val="8AA0B2"/>
+                </a:solidFill>
+                <a:latin typeface="Calibri" pitchFamily="34" charset="0"/>
+                <a:ea typeface="Calibri" pitchFamily="34" charset="-122"/>
+                <a:cs typeface="Calibri" pitchFamily="34" charset="-120"/>
+              </a:rPr>
+              <a:t>Vidrio translúcido con blur y modo claro/oscuro instantáneo. Tus datos, tu estilo.</a:t>
+            </a:r>
+            <a:endParaRPr lang="en-US" sz="1300" dirty="0"/>
+          </a:p>
+        </p:txBody>
+      </p:sp>
+      <p:sp>
+        <p:nvSpPr>
+          <p:cNvPr id="18" name="Text 16"/>
           <p:cNvSpPr/>
           <p:nvPr/>
         </p:nvSpPr>
@@ -8955,7 +10371,7 @@
       </p:sp>
       <p:sp>
         <p:nvSpPr>
-          <p:cNvPr id="18" name="Text 16"/>
+          <p:cNvPr id="19" name="Text 17"/>
           <p:cNvSpPr/>
           <p:nvPr/>
         </p:nvSpPr>
@@ -8978,7 +10394,7 @@
               <a:buNone/>
             </a:pPr>
             <a:r>
-              <a:rPr lang="en-US" sz="900" dirty="0">
+              <a:rPr lang="en-US" sz="900" dirty="0" b="0">
                 <a:solidFill>
                   <a:srgbClr val="8AA0B2"/>
                 </a:solidFill>

</xml_diff>